<commit_message>
progress on thursdays presentation
</commit_message>
<xml_diff>
--- a/deliverables/michaelmas_presentation.pptx
+++ b/deliverables/michaelmas_presentation.pptx
@@ -4,6 +4,9 @@
   <p:sldMasterIdLst>
     <p:sldMasterId id="2147483648" r:id="rId1"/>
   </p:sldMasterIdLst>
+  <p:notesMasterIdLst>
+    <p:notesMasterId r:id="rId11"/>
+  </p:notesMasterIdLst>
   <p:sldIdLst>
     <p:sldId id="256" r:id="rId2"/>
     <p:sldId id="257" r:id="rId3"/>
@@ -11,7 +14,9 @@
     <p:sldId id="259" r:id="rId5"/>
     <p:sldId id="260" r:id="rId6"/>
     <p:sldId id="261" r:id="rId7"/>
-    <p:sldId id="262" r:id="rId8"/>
+    <p:sldId id="263" r:id="rId8"/>
+    <p:sldId id="264" r:id="rId9"/>
+    <p:sldId id="262" r:id="rId10"/>
   </p:sldIdLst>
   <p:sldSz cx="12192000" cy="6858000"/>
   <p:notesSz cx="6858000" cy="9144000"/>
@@ -110,7 +115,542 @@
       </a:defRPr>
     </a:lvl9pPr>
   </p:defaultTextStyle>
+  <p:extLst>
+    <p:ext uri="{EFAFB233-063F-42B5-8137-9DF3F51BA10A}">
+      <p15:sldGuideLst xmlns:p15="http://schemas.microsoft.com/office/powerpoint/2012/main"/>
+    </p:ext>
+  </p:extLst>
 </p:presentation>
+</file>
+
+<file path=ppt/notesMasters/notesMaster1.xml><?xml version="1.0" encoding="utf-8"?>
+<p:notesMaster xmlns:a="http://schemas.openxmlformats.org/drawingml/2006/main" xmlns:r="http://schemas.openxmlformats.org/officeDocument/2006/relationships" xmlns:p="http://schemas.openxmlformats.org/presentationml/2006/main">
+  <p:cSld>
+    <p:bg>
+      <p:bgRef idx="1001">
+        <a:schemeClr val="bg1"/>
+      </p:bgRef>
+    </p:bg>
+    <p:spTree>
+      <p:nvGrpSpPr>
+        <p:cNvPr id="1" name=""/>
+        <p:cNvGrpSpPr/>
+        <p:nvPr/>
+      </p:nvGrpSpPr>
+      <p:grpSpPr>
+        <a:xfrm>
+          <a:off x="0" y="0"/>
+          <a:ext cx="0" cy="0"/>
+          <a:chOff x="0" y="0"/>
+          <a:chExt cx="0" cy="0"/>
+        </a:xfrm>
+      </p:grpSpPr>
+      <p:sp>
+        <p:nvSpPr>
+          <p:cNvPr id="2" name="Header Placeholder 1"/>
+          <p:cNvSpPr>
+            <a:spLocks noGrp="1"/>
+          </p:cNvSpPr>
+          <p:nvPr>
+            <p:ph type="hdr" sz="quarter"/>
+          </p:nvPr>
+        </p:nvSpPr>
+        <p:spPr>
+          <a:xfrm>
+            <a:off x="0" y="0"/>
+            <a:ext cx="2971800" cy="458788"/>
+          </a:xfrm>
+          <a:prstGeom prst="rect">
+            <a:avLst/>
+          </a:prstGeom>
+        </p:spPr>
+        <p:txBody>
+          <a:bodyPr vert="horz" lIns="91440" tIns="45720" rIns="91440" bIns="45720" rtlCol="0"/>
+          <a:lstStyle>
+            <a:lvl1pPr algn="l">
+              <a:defRPr sz="1200"/>
+            </a:lvl1pPr>
+          </a:lstStyle>
+          <a:p>
+            <a:endParaRPr lang="en-GB"/>
+          </a:p>
+        </p:txBody>
+      </p:sp>
+      <p:sp>
+        <p:nvSpPr>
+          <p:cNvPr id="3" name="Date Placeholder 2"/>
+          <p:cNvSpPr>
+            <a:spLocks noGrp="1"/>
+          </p:cNvSpPr>
+          <p:nvPr>
+            <p:ph type="dt" idx="1"/>
+          </p:nvPr>
+        </p:nvSpPr>
+        <p:spPr>
+          <a:xfrm>
+            <a:off x="3884613" y="0"/>
+            <a:ext cx="2971800" cy="458788"/>
+          </a:xfrm>
+          <a:prstGeom prst="rect">
+            <a:avLst/>
+          </a:prstGeom>
+        </p:spPr>
+        <p:txBody>
+          <a:bodyPr vert="horz" lIns="91440" tIns="45720" rIns="91440" bIns="45720" rtlCol="0"/>
+          <a:lstStyle>
+            <a:lvl1pPr algn="r">
+              <a:defRPr sz="1200"/>
+            </a:lvl1pPr>
+          </a:lstStyle>
+          <a:p>
+            <a:fld id="{C0BB89D3-1E85-48CA-BFDB-0FE03B3C9B40}" type="datetimeFigureOut">
+              <a:rPr lang="en-GB" smtClean="0"/>
+              <a:t>24/11/2024</a:t>
+            </a:fld>
+            <a:endParaRPr lang="en-GB"/>
+          </a:p>
+        </p:txBody>
+      </p:sp>
+      <p:sp>
+        <p:nvSpPr>
+          <p:cNvPr id="4" name="Slide Image Placeholder 3"/>
+          <p:cNvSpPr>
+            <a:spLocks noGrp="1" noRot="1" noChangeAspect="1"/>
+          </p:cNvSpPr>
+          <p:nvPr>
+            <p:ph type="sldImg" idx="2"/>
+          </p:nvPr>
+        </p:nvSpPr>
+        <p:spPr>
+          <a:xfrm>
+            <a:off x="685800" y="1143000"/>
+            <a:ext cx="5486400" cy="3086100"/>
+          </a:xfrm>
+          <a:prstGeom prst="rect">
+            <a:avLst/>
+          </a:prstGeom>
+          <a:noFill/>
+          <a:ln w="12700">
+            <a:solidFill>
+              <a:prstClr val="black"/>
+            </a:solidFill>
+          </a:ln>
+        </p:spPr>
+        <p:txBody>
+          <a:bodyPr vert="horz" lIns="91440" tIns="45720" rIns="91440" bIns="45720" rtlCol="0" anchor="ctr"/>
+          <a:lstStyle/>
+          <a:p>
+            <a:endParaRPr lang="en-GB"/>
+          </a:p>
+        </p:txBody>
+      </p:sp>
+      <p:sp>
+        <p:nvSpPr>
+          <p:cNvPr id="5" name="Notes Placeholder 4"/>
+          <p:cNvSpPr>
+            <a:spLocks noGrp="1"/>
+          </p:cNvSpPr>
+          <p:nvPr>
+            <p:ph type="body" sz="quarter" idx="3"/>
+          </p:nvPr>
+        </p:nvSpPr>
+        <p:spPr>
+          <a:xfrm>
+            <a:off x="685800" y="4400550"/>
+            <a:ext cx="5486400" cy="3600450"/>
+          </a:xfrm>
+          <a:prstGeom prst="rect">
+            <a:avLst/>
+          </a:prstGeom>
+        </p:spPr>
+        <p:txBody>
+          <a:bodyPr vert="horz" lIns="91440" tIns="45720" rIns="91440" bIns="45720" rtlCol="0"/>
+          <a:lstStyle/>
+          <a:p>
+            <a:pPr lvl="0"/>
+            <a:r>
+              <a:rPr lang="en-US"/>
+              <a:t>Click to edit Master text styles</a:t>
+            </a:r>
+          </a:p>
+          <a:p>
+            <a:pPr lvl="1"/>
+            <a:r>
+              <a:rPr lang="en-US"/>
+              <a:t>Second level</a:t>
+            </a:r>
+          </a:p>
+          <a:p>
+            <a:pPr lvl="2"/>
+            <a:r>
+              <a:rPr lang="en-US"/>
+              <a:t>Third level</a:t>
+            </a:r>
+          </a:p>
+          <a:p>
+            <a:pPr lvl="3"/>
+            <a:r>
+              <a:rPr lang="en-US"/>
+              <a:t>Fourth level</a:t>
+            </a:r>
+          </a:p>
+          <a:p>
+            <a:pPr lvl="4"/>
+            <a:r>
+              <a:rPr lang="en-US"/>
+              <a:t>Fifth level</a:t>
+            </a:r>
+            <a:endParaRPr lang="en-GB"/>
+          </a:p>
+        </p:txBody>
+      </p:sp>
+      <p:sp>
+        <p:nvSpPr>
+          <p:cNvPr id="6" name="Footer Placeholder 5"/>
+          <p:cNvSpPr>
+            <a:spLocks noGrp="1"/>
+          </p:cNvSpPr>
+          <p:nvPr>
+            <p:ph type="ftr" sz="quarter" idx="4"/>
+          </p:nvPr>
+        </p:nvSpPr>
+        <p:spPr>
+          <a:xfrm>
+            <a:off x="0" y="8685213"/>
+            <a:ext cx="2971800" cy="458787"/>
+          </a:xfrm>
+          <a:prstGeom prst="rect">
+            <a:avLst/>
+          </a:prstGeom>
+        </p:spPr>
+        <p:txBody>
+          <a:bodyPr vert="horz" lIns="91440" tIns="45720" rIns="91440" bIns="45720" rtlCol="0" anchor="b"/>
+          <a:lstStyle>
+            <a:lvl1pPr algn="l">
+              <a:defRPr sz="1200"/>
+            </a:lvl1pPr>
+          </a:lstStyle>
+          <a:p>
+            <a:endParaRPr lang="en-GB"/>
+          </a:p>
+        </p:txBody>
+      </p:sp>
+      <p:sp>
+        <p:nvSpPr>
+          <p:cNvPr id="7" name="Slide Number Placeholder 6"/>
+          <p:cNvSpPr>
+            <a:spLocks noGrp="1"/>
+          </p:cNvSpPr>
+          <p:nvPr>
+            <p:ph type="sldNum" sz="quarter" idx="5"/>
+          </p:nvPr>
+        </p:nvSpPr>
+        <p:spPr>
+          <a:xfrm>
+            <a:off x="3884613" y="8685213"/>
+            <a:ext cx="2971800" cy="458787"/>
+          </a:xfrm>
+          <a:prstGeom prst="rect">
+            <a:avLst/>
+          </a:prstGeom>
+        </p:spPr>
+        <p:txBody>
+          <a:bodyPr vert="horz" lIns="91440" tIns="45720" rIns="91440" bIns="45720" rtlCol="0" anchor="b"/>
+          <a:lstStyle>
+            <a:lvl1pPr algn="r">
+              <a:defRPr sz="1200"/>
+            </a:lvl1pPr>
+          </a:lstStyle>
+          <a:p>
+            <a:fld id="{339AB5C0-8D71-4250-8AD2-76EE22722959}" type="slidenum">
+              <a:rPr lang="en-GB" smtClean="0"/>
+              <a:t>‹#›</a:t>
+            </a:fld>
+            <a:endParaRPr lang="en-GB"/>
+          </a:p>
+        </p:txBody>
+      </p:sp>
+    </p:spTree>
+    <p:extLst>
+      <p:ext uri="{BB962C8B-B14F-4D97-AF65-F5344CB8AC3E}">
+        <p14:creationId xmlns:p14="http://schemas.microsoft.com/office/powerpoint/2010/main" val="2764755657"/>
+      </p:ext>
+    </p:extLst>
+  </p:cSld>
+  <p:clrMap bg1="lt1" tx1="dk1" bg2="lt2" tx2="dk2" accent1="accent1" accent2="accent2" accent3="accent3" accent4="accent4" accent5="accent5" accent6="accent6" hlink="hlink" folHlink="folHlink"/>
+  <p:notesStyle>
+    <a:lvl1pPr marL="0" algn="l" defTabSz="914400" rtl="0" eaLnBrk="1" latinLnBrk="0" hangingPunct="1">
+      <a:defRPr sz="1200" kern="1200">
+        <a:solidFill>
+          <a:schemeClr val="tx1"/>
+        </a:solidFill>
+        <a:latin typeface="+mn-lt"/>
+        <a:ea typeface="+mn-ea"/>
+        <a:cs typeface="+mn-cs"/>
+      </a:defRPr>
+    </a:lvl1pPr>
+    <a:lvl2pPr marL="457200" algn="l" defTabSz="914400" rtl="0" eaLnBrk="1" latinLnBrk="0" hangingPunct="1">
+      <a:defRPr sz="1200" kern="1200">
+        <a:solidFill>
+          <a:schemeClr val="tx1"/>
+        </a:solidFill>
+        <a:latin typeface="+mn-lt"/>
+        <a:ea typeface="+mn-ea"/>
+        <a:cs typeface="+mn-cs"/>
+      </a:defRPr>
+    </a:lvl2pPr>
+    <a:lvl3pPr marL="914400" algn="l" defTabSz="914400" rtl="0" eaLnBrk="1" latinLnBrk="0" hangingPunct="1">
+      <a:defRPr sz="1200" kern="1200">
+        <a:solidFill>
+          <a:schemeClr val="tx1"/>
+        </a:solidFill>
+        <a:latin typeface="+mn-lt"/>
+        <a:ea typeface="+mn-ea"/>
+        <a:cs typeface="+mn-cs"/>
+      </a:defRPr>
+    </a:lvl3pPr>
+    <a:lvl4pPr marL="1371600" algn="l" defTabSz="914400" rtl="0" eaLnBrk="1" latinLnBrk="0" hangingPunct="1">
+      <a:defRPr sz="1200" kern="1200">
+        <a:solidFill>
+          <a:schemeClr val="tx1"/>
+        </a:solidFill>
+        <a:latin typeface="+mn-lt"/>
+        <a:ea typeface="+mn-ea"/>
+        <a:cs typeface="+mn-cs"/>
+      </a:defRPr>
+    </a:lvl4pPr>
+    <a:lvl5pPr marL="1828800" algn="l" defTabSz="914400" rtl="0" eaLnBrk="1" latinLnBrk="0" hangingPunct="1">
+      <a:defRPr sz="1200" kern="1200">
+        <a:solidFill>
+          <a:schemeClr val="tx1"/>
+        </a:solidFill>
+        <a:latin typeface="+mn-lt"/>
+        <a:ea typeface="+mn-ea"/>
+        <a:cs typeface="+mn-cs"/>
+      </a:defRPr>
+    </a:lvl5pPr>
+    <a:lvl6pPr marL="2286000" algn="l" defTabSz="914400" rtl="0" eaLnBrk="1" latinLnBrk="0" hangingPunct="1">
+      <a:defRPr sz="1200" kern="1200">
+        <a:solidFill>
+          <a:schemeClr val="tx1"/>
+        </a:solidFill>
+        <a:latin typeface="+mn-lt"/>
+        <a:ea typeface="+mn-ea"/>
+        <a:cs typeface="+mn-cs"/>
+      </a:defRPr>
+    </a:lvl6pPr>
+    <a:lvl7pPr marL="2743200" algn="l" defTabSz="914400" rtl="0" eaLnBrk="1" latinLnBrk="0" hangingPunct="1">
+      <a:defRPr sz="1200" kern="1200">
+        <a:solidFill>
+          <a:schemeClr val="tx1"/>
+        </a:solidFill>
+        <a:latin typeface="+mn-lt"/>
+        <a:ea typeface="+mn-ea"/>
+        <a:cs typeface="+mn-cs"/>
+      </a:defRPr>
+    </a:lvl7pPr>
+    <a:lvl8pPr marL="3200400" algn="l" defTabSz="914400" rtl="0" eaLnBrk="1" latinLnBrk="0" hangingPunct="1">
+      <a:defRPr sz="1200" kern="1200">
+        <a:solidFill>
+          <a:schemeClr val="tx1"/>
+        </a:solidFill>
+        <a:latin typeface="+mn-lt"/>
+        <a:ea typeface="+mn-ea"/>
+        <a:cs typeface="+mn-cs"/>
+      </a:defRPr>
+    </a:lvl8pPr>
+    <a:lvl9pPr marL="3657600" algn="l" defTabSz="914400" rtl="0" eaLnBrk="1" latinLnBrk="0" hangingPunct="1">
+      <a:defRPr sz="1200" kern="1200">
+        <a:solidFill>
+          <a:schemeClr val="tx1"/>
+        </a:solidFill>
+        <a:latin typeface="+mn-lt"/>
+        <a:ea typeface="+mn-ea"/>
+        <a:cs typeface="+mn-cs"/>
+      </a:defRPr>
+    </a:lvl9pPr>
+  </p:notesStyle>
+</p:notesMaster>
+</file>
+
+<file path=ppt/notesSlides/notesSlide1.xml><?xml version="1.0" encoding="utf-8"?>
+<p:notes xmlns:a="http://schemas.openxmlformats.org/drawingml/2006/main" xmlns:r="http://schemas.openxmlformats.org/officeDocument/2006/relationships" xmlns:p="http://schemas.openxmlformats.org/presentationml/2006/main">
+  <p:cSld>
+    <p:spTree>
+      <p:nvGrpSpPr>
+        <p:cNvPr id="1" name=""/>
+        <p:cNvGrpSpPr/>
+        <p:nvPr/>
+      </p:nvGrpSpPr>
+      <p:grpSpPr>
+        <a:xfrm>
+          <a:off x="0" y="0"/>
+          <a:ext cx="0" cy="0"/>
+          <a:chOff x="0" y="0"/>
+          <a:chExt cx="0" cy="0"/>
+        </a:xfrm>
+      </p:grpSpPr>
+      <p:sp>
+        <p:nvSpPr>
+          <p:cNvPr id="2" name="Slide Image Placeholder 1"/>
+          <p:cNvSpPr>
+            <a:spLocks noGrp="1" noRot="1" noChangeAspect="1"/>
+          </p:cNvSpPr>
+          <p:nvPr>
+            <p:ph type="sldImg"/>
+          </p:nvPr>
+        </p:nvSpPr>
+        <p:spPr/>
+      </p:sp>
+      <p:sp>
+        <p:nvSpPr>
+          <p:cNvPr id="3" name="Notes Placeholder 2"/>
+          <p:cNvSpPr>
+            <a:spLocks noGrp="1"/>
+          </p:cNvSpPr>
+          <p:nvPr>
+            <p:ph type="body" idx="1"/>
+          </p:nvPr>
+        </p:nvSpPr>
+        <p:spPr/>
+        <p:txBody>
+          <a:bodyPr/>
+          <a:lstStyle/>
+          <a:p>
+            <a:r>
+              <a:rPr lang="en-GB" dirty="0"/>
+              <a:t>For the experimental setup it's important to consider the parameters needed to define a given propellers performance. Dimensionless thrust and power coefficients can be found from blade tip speed and area. The ratio of these coefficients define a ‘static’ efficiency which is different to the typical propulsive efficiency. The values then required to be measured are the torque, thrust and angular speed.</a:t>
+            </a:r>
+          </a:p>
+          <a:p>
+            <a:r>
+              <a:rPr lang="en-GB" dirty="0"/>
+              <a:t>Dynamic measurements of torque and angular velocity could be fused together in a Kalman filter</a:t>
+            </a:r>
+          </a:p>
+        </p:txBody>
+      </p:sp>
+      <p:sp>
+        <p:nvSpPr>
+          <p:cNvPr id="4" name="Slide Number Placeholder 3"/>
+          <p:cNvSpPr>
+            <a:spLocks noGrp="1"/>
+          </p:cNvSpPr>
+          <p:nvPr>
+            <p:ph type="sldNum" sz="quarter" idx="5"/>
+          </p:nvPr>
+        </p:nvSpPr>
+        <p:spPr/>
+        <p:txBody>
+          <a:bodyPr/>
+          <a:lstStyle/>
+          <a:p>
+            <a:fld id="{339AB5C0-8D71-4250-8AD2-76EE22722959}" type="slidenum">
+              <a:rPr lang="en-GB" smtClean="0"/>
+              <a:t>6</a:t>
+            </a:fld>
+            <a:endParaRPr lang="en-GB"/>
+          </a:p>
+        </p:txBody>
+      </p:sp>
+    </p:spTree>
+    <p:extLst>
+      <p:ext uri="{BB962C8B-B14F-4D97-AF65-F5344CB8AC3E}">
+        <p14:creationId xmlns:p14="http://schemas.microsoft.com/office/powerpoint/2010/main" val="1790782265"/>
+      </p:ext>
+    </p:extLst>
+  </p:cSld>
+  <p:clrMapOvr>
+    <a:masterClrMapping/>
+  </p:clrMapOvr>
+</p:notes>
+</file>
+
+<file path=ppt/notesSlides/notesSlide2.xml><?xml version="1.0" encoding="utf-8"?>
+<p:notes xmlns:a="http://schemas.openxmlformats.org/drawingml/2006/main" xmlns:r="http://schemas.openxmlformats.org/officeDocument/2006/relationships" xmlns:p="http://schemas.openxmlformats.org/presentationml/2006/main">
+  <p:cSld>
+    <p:spTree>
+      <p:nvGrpSpPr>
+        <p:cNvPr id="1" name=""/>
+        <p:cNvGrpSpPr/>
+        <p:nvPr/>
+      </p:nvGrpSpPr>
+      <p:grpSpPr>
+        <a:xfrm>
+          <a:off x="0" y="0"/>
+          <a:ext cx="0" cy="0"/>
+          <a:chOff x="0" y="0"/>
+          <a:chExt cx="0" cy="0"/>
+        </a:xfrm>
+      </p:grpSpPr>
+      <p:sp>
+        <p:nvSpPr>
+          <p:cNvPr id="2" name="Slide Image Placeholder 1"/>
+          <p:cNvSpPr>
+            <a:spLocks noGrp="1" noRot="1" noChangeAspect="1"/>
+          </p:cNvSpPr>
+          <p:nvPr>
+            <p:ph type="sldImg"/>
+          </p:nvPr>
+        </p:nvSpPr>
+        <p:spPr/>
+      </p:sp>
+      <p:sp>
+        <p:nvSpPr>
+          <p:cNvPr id="3" name="Notes Placeholder 2"/>
+          <p:cNvSpPr>
+            <a:spLocks noGrp="1"/>
+          </p:cNvSpPr>
+          <p:nvPr>
+            <p:ph type="body" idx="1"/>
+          </p:nvPr>
+        </p:nvSpPr>
+        <p:spPr/>
+        <p:txBody>
+          <a:bodyPr/>
+          <a:lstStyle/>
+          <a:p>
+            <a:r>
+              <a:rPr lang="en-GB" dirty="0"/>
+              <a:t>To measure torque and thrust the deflection of load cells will be measured by strain gauges. This was preferred over null force balancing methods for its simple setup and ability to measure dynamic torque.</a:t>
+            </a:r>
+          </a:p>
+        </p:txBody>
+      </p:sp>
+      <p:sp>
+        <p:nvSpPr>
+          <p:cNvPr id="4" name="Slide Number Placeholder 3"/>
+          <p:cNvSpPr>
+            <a:spLocks noGrp="1"/>
+          </p:cNvSpPr>
+          <p:nvPr>
+            <p:ph type="sldNum" sz="quarter" idx="5"/>
+          </p:nvPr>
+        </p:nvSpPr>
+        <p:spPr/>
+        <p:txBody>
+          <a:bodyPr/>
+          <a:lstStyle/>
+          <a:p>
+            <a:fld id="{339AB5C0-8D71-4250-8AD2-76EE22722959}" type="slidenum">
+              <a:rPr lang="en-GB" smtClean="0"/>
+              <a:t>7</a:t>
+            </a:fld>
+            <a:endParaRPr lang="en-GB"/>
+          </a:p>
+        </p:txBody>
+      </p:sp>
+    </p:spTree>
+    <p:extLst>
+      <p:ext uri="{BB962C8B-B14F-4D97-AF65-F5344CB8AC3E}">
+        <p14:creationId xmlns:p14="http://schemas.microsoft.com/office/powerpoint/2010/main" val="1624805185"/>
+      </p:ext>
+    </p:extLst>
+  </p:cSld>
+  <p:clrMapOvr>
+    <a:masterClrMapping/>
+  </p:clrMapOvr>
+</p:notes>
 </file>
 
 <file path=ppt/slideLayouts/slideLayout1.xml><?xml version="1.0" encoding="utf-8"?>
@@ -262,7 +802,7 @@
           <a:p>
             <a:fld id="{B8C3C57F-C92A-483E-A8E5-2F94B59C9323}" type="datetimeFigureOut">
               <a:rPr lang="en-GB" smtClean="0"/>
-              <a:t>22/11/2024</a:t>
+              <a:t>24/11/2024</a:t>
             </a:fld>
             <a:endParaRPr lang="en-GB"/>
           </a:p>
@@ -462,7 +1002,7 @@
           <a:p>
             <a:fld id="{B8C3C57F-C92A-483E-A8E5-2F94B59C9323}" type="datetimeFigureOut">
               <a:rPr lang="en-GB" smtClean="0"/>
-              <a:t>22/11/2024</a:t>
+              <a:t>24/11/2024</a:t>
             </a:fld>
             <a:endParaRPr lang="en-GB"/>
           </a:p>
@@ -672,7 +1212,7 @@
           <a:p>
             <a:fld id="{B8C3C57F-C92A-483E-A8E5-2F94B59C9323}" type="datetimeFigureOut">
               <a:rPr lang="en-GB" smtClean="0"/>
-              <a:t>22/11/2024</a:t>
+              <a:t>24/11/2024</a:t>
             </a:fld>
             <a:endParaRPr lang="en-GB"/>
           </a:p>
@@ -872,7 +1412,7 @@
           <a:p>
             <a:fld id="{B8C3C57F-C92A-483E-A8E5-2F94B59C9323}" type="datetimeFigureOut">
               <a:rPr lang="en-GB" smtClean="0"/>
-              <a:t>22/11/2024</a:t>
+              <a:t>24/11/2024</a:t>
             </a:fld>
             <a:endParaRPr lang="en-GB"/>
           </a:p>
@@ -1148,7 +1688,7 @@
           <a:p>
             <a:fld id="{B8C3C57F-C92A-483E-A8E5-2F94B59C9323}" type="datetimeFigureOut">
               <a:rPr lang="en-GB" smtClean="0"/>
-              <a:t>22/11/2024</a:t>
+              <a:t>24/11/2024</a:t>
             </a:fld>
             <a:endParaRPr lang="en-GB"/>
           </a:p>
@@ -1416,7 +1956,7 @@
           <a:p>
             <a:fld id="{B8C3C57F-C92A-483E-A8E5-2F94B59C9323}" type="datetimeFigureOut">
               <a:rPr lang="en-GB" smtClean="0"/>
-              <a:t>22/11/2024</a:t>
+              <a:t>24/11/2024</a:t>
             </a:fld>
             <a:endParaRPr lang="en-GB"/>
           </a:p>
@@ -1831,7 +2371,7 @@
           <a:p>
             <a:fld id="{B8C3C57F-C92A-483E-A8E5-2F94B59C9323}" type="datetimeFigureOut">
               <a:rPr lang="en-GB" smtClean="0"/>
-              <a:t>22/11/2024</a:t>
+              <a:t>24/11/2024</a:t>
             </a:fld>
             <a:endParaRPr lang="en-GB"/>
           </a:p>
@@ -1973,7 +2513,7 @@
           <a:p>
             <a:fld id="{B8C3C57F-C92A-483E-A8E5-2F94B59C9323}" type="datetimeFigureOut">
               <a:rPr lang="en-GB" smtClean="0"/>
-              <a:t>22/11/2024</a:t>
+              <a:t>24/11/2024</a:t>
             </a:fld>
             <a:endParaRPr lang="en-GB"/>
           </a:p>
@@ -2086,7 +2626,7 @@
           <a:p>
             <a:fld id="{B8C3C57F-C92A-483E-A8E5-2F94B59C9323}" type="datetimeFigureOut">
               <a:rPr lang="en-GB" smtClean="0"/>
-              <a:t>22/11/2024</a:t>
+              <a:t>24/11/2024</a:t>
             </a:fld>
             <a:endParaRPr lang="en-GB"/>
           </a:p>
@@ -2399,7 +2939,7 @@
           <a:p>
             <a:fld id="{B8C3C57F-C92A-483E-A8E5-2F94B59C9323}" type="datetimeFigureOut">
               <a:rPr lang="en-GB" smtClean="0"/>
-              <a:t>22/11/2024</a:t>
+              <a:t>24/11/2024</a:t>
             </a:fld>
             <a:endParaRPr lang="en-GB"/>
           </a:p>
@@ -2688,7 +3228,7 @@
           <a:p>
             <a:fld id="{B8C3C57F-C92A-483E-A8E5-2F94B59C9323}" type="datetimeFigureOut">
               <a:rPr lang="en-GB" smtClean="0"/>
-              <a:t>22/11/2024</a:t>
+              <a:t>24/11/2024</a:t>
             </a:fld>
             <a:endParaRPr lang="en-GB"/>
           </a:p>
@@ -2931,7 +3471,7 @@
           <a:p>
             <a:fld id="{B8C3C57F-C92A-483E-A8E5-2F94B59C9323}" type="datetimeFigureOut">
               <a:rPr lang="en-GB" smtClean="0"/>
-              <a:t>22/11/2024</a:t>
+              <a:t>24/11/2024</a:t>
             </a:fld>
             <a:endParaRPr lang="en-GB"/>
           </a:p>
@@ -3480,27 +4020,42 @@
           <a:bodyPr/>
           <a:lstStyle/>
           <a:p>
+            <a:endParaRPr lang="en-GB" dirty="0"/>
+          </a:p>
+          <a:p>
+            <a:pPr marL="0" indent="0">
+              <a:buNone/>
+            </a:pPr>
             <a:r>
               <a:rPr lang="en-GB" dirty="0"/>
-              <a:t>Wider purpose and application </a:t>
-            </a:r>
-          </a:p>
-          <a:p>
+              <a:t>Public perception of drones is poor due to the annoying sound that they make.</a:t>
+            </a:r>
+          </a:p>
+          <a:p>
+            <a:pPr marL="0" indent="0">
+              <a:buNone/>
+            </a:pPr>
+            <a:endParaRPr lang="en-GB" dirty="0"/>
+          </a:p>
+          <a:p>
+            <a:pPr marL="0" indent="0">
+              <a:buNone/>
+            </a:pPr>
             <a:r>
               <a:rPr lang="en-GB" dirty="0"/>
-              <a:t>First slide should be attention grabbing</a:t>
+              <a:t>This, and other legislative barriers, prevent the adoption of drone-based services in urban environments.</a:t>
             </a:r>
           </a:p>
           <a:p>
             <a:endParaRPr lang="en-GB" dirty="0"/>
           </a:p>
           <a:p>
-            <a:endParaRPr lang="en-GB" dirty="0"/>
-          </a:p>
-          <a:p>
+            <a:pPr marL="0" indent="0">
+              <a:buNone/>
+            </a:pPr>
             <a:r>
               <a:rPr lang="en-GB" dirty="0"/>
-              <a:t>Recent research interest</a:t>
+              <a:t>Recent research has focused on optimising aerodynamic and aeroacoustics performance to overcome these barriers.</a:t>
             </a:r>
           </a:p>
           <a:p>
@@ -3626,7 +4181,15 @@
           <a:p>
             <a:r>
               <a:rPr lang="en-GB" dirty="0"/>
-              <a:t>Attribute changes in measured acoustic spectrum to changes in propeller geometry.</a:t>
+              <a:t>Attribute </a:t>
+            </a:r>
+            <a:r>
+              <a:rPr lang="en-US" dirty="0"/>
+              <a:t>changes in the acoustic spectrum to flow phenomena caused by propeller geometry modifications</a:t>
+            </a:r>
+            <a:r>
+              <a:rPr lang="en-GB" dirty="0"/>
+              <a:t>.</a:t>
             </a:r>
           </a:p>
           <a:p>
@@ -3635,7 +4198,7 @@
           <a:p>
             <a:r>
               <a:rPr lang="en-GB" dirty="0"/>
-              <a:t>Identify a trade-off between aerodynamic performance and acoustic annoyance</a:t>
+              <a:t>Analyse psychoacoustic performance </a:t>
             </a:r>
           </a:p>
           <a:p>
@@ -3689,14 +4252,19 @@
             <p:ph type="title"/>
           </p:nvPr>
         </p:nvSpPr>
-        <p:spPr/>
+        <p:spPr>
+          <a:xfrm>
+            <a:off x="499202" y="152898"/>
+            <a:ext cx="10515600" cy="1325563"/>
+          </a:xfrm>
+        </p:spPr>
         <p:txBody>
           <a:bodyPr/>
           <a:lstStyle/>
           <a:p>
             <a:r>
               <a:rPr lang="en-GB" dirty="0"/>
-              <a:t>Propeller geometry modifications</a:t>
+              <a:t>Propeller geometry</a:t>
             </a:r>
           </a:p>
         </p:txBody>
@@ -3717,58 +4285,150 @@
             <p:ph idx="1"/>
           </p:nvPr>
         </p:nvSpPr>
-        <p:spPr/>
-        <p:txBody>
-          <a:bodyPr/>
+        <p:spPr>
+          <a:xfrm>
+            <a:off x="499202" y="1394845"/>
+            <a:ext cx="10515600" cy="4906993"/>
+          </a:xfrm>
+        </p:spPr>
+        <p:txBody>
+          <a:bodyPr>
+            <a:normAutofit/>
+          </a:bodyPr>
           <a:lstStyle/>
           <a:p>
             <a:r>
               <a:rPr lang="en-GB" sz="3200" dirty="0"/>
-              <a:t>Current research has covered changes in</a:t>
+              <a:t>Consideration for Toroidal designs</a:t>
+            </a:r>
+          </a:p>
+          <a:p>
+            <a:endParaRPr lang="en-GB" sz="3200" dirty="0"/>
+          </a:p>
+          <a:p>
+            <a:r>
+              <a:rPr lang="en-GB" sz="3200" dirty="0"/>
+              <a:t>Previous research has covered:</a:t>
             </a:r>
           </a:p>
           <a:p>
             <a:pPr lvl="1"/>
             <a:r>
               <a:rPr lang="en-GB" sz="2800" dirty="0"/>
-              <a:t>tip geometry</a:t>
+              <a:t>Tip geometry</a:t>
             </a:r>
           </a:p>
           <a:p>
             <a:pPr lvl="1"/>
             <a:r>
               <a:rPr lang="en-GB" sz="2800" dirty="0"/>
-              <a:t>sweep</a:t>
+              <a:t>Blade sweep</a:t>
             </a:r>
           </a:p>
           <a:p>
             <a:pPr lvl="1"/>
             <a:r>
               <a:rPr lang="en-GB" sz="2800" dirty="0"/>
-              <a:t>blade spacing</a:t>
+              <a:t>Blade spacing</a:t>
             </a:r>
           </a:p>
           <a:p>
             <a:pPr lvl="1"/>
             <a:r>
               <a:rPr lang="en-GB" sz="2800" dirty="0"/>
-              <a:t>blade span</a:t>
-            </a:r>
-          </a:p>
-          <a:p>
-            <a:r>
-              <a:rPr lang="en-GB" sz="3200" dirty="0"/>
-              <a:t>Research into toroidal propellers is limited</a:t>
-            </a:r>
+              <a:t>Trailing edge serrations</a:t>
+            </a:r>
+          </a:p>
+          <a:p>
+            <a:endParaRPr lang="en-GB" dirty="0"/>
           </a:p>
           <a:p>
             <a:r>
               <a:rPr lang="en-GB" dirty="0"/>
-              <a:t> </a:t>
-            </a:r>
-          </a:p>
-        </p:txBody>
-      </p:sp>
+              <a:t>Varying blade span</a:t>
+            </a:r>
+          </a:p>
+        </p:txBody>
+      </p:sp>
+      <p:sp>
+        <p:nvSpPr>
+          <p:cNvPr id="5" name="Rectangle 4">
+            <a:extLst>
+              <a:ext uri="{FF2B5EF4-FFF2-40B4-BE49-F238E27FC236}">
+                <a16:creationId xmlns:a16="http://schemas.microsoft.com/office/drawing/2014/main" id="{590A1BD3-F005-347F-02C8-AFF37807D7C4}"/>
+              </a:ext>
+            </a:extLst>
+          </p:cNvPr>
+          <p:cNvSpPr/>
+          <p:nvPr/>
+        </p:nvSpPr>
+        <p:spPr>
+          <a:xfrm>
+            <a:off x="7128290" y="332960"/>
+            <a:ext cx="4942784" cy="5769665"/>
+          </a:xfrm>
+          <a:prstGeom prst="rect">
+            <a:avLst/>
+          </a:prstGeom>
+        </p:spPr>
+        <p:style>
+          <a:lnRef idx="2">
+            <a:schemeClr val="accent1">
+              <a:shade val="15000"/>
+            </a:schemeClr>
+          </a:lnRef>
+          <a:fillRef idx="1">
+            <a:schemeClr val="accent1"/>
+          </a:fillRef>
+          <a:effectRef idx="0">
+            <a:schemeClr val="accent1"/>
+          </a:effectRef>
+          <a:fontRef idx="minor">
+            <a:schemeClr val="lt1"/>
+          </a:fontRef>
+        </p:style>
+        <p:txBody>
+          <a:bodyPr rtlCol="0" anchor="ctr"/>
+          <a:lstStyle/>
+          <a:p>
+            <a:pPr algn="ctr"/>
+            <a:r>
+              <a:rPr lang="en-GB" dirty="0"/>
+              <a:t>TOROIDAL PROPELLERS</a:t>
+            </a:r>
+          </a:p>
+        </p:txBody>
+      </p:sp>
+      <p:pic>
+        <p:nvPicPr>
+          <p:cNvPr id="4" name="Picture 3">
+            <a:extLst>
+              <a:ext uri="{FF2B5EF4-FFF2-40B4-BE49-F238E27FC236}">
+                <a16:creationId xmlns:a16="http://schemas.microsoft.com/office/drawing/2014/main" id="{8E28C63F-94ED-AE22-8F66-C521AF20E882}"/>
+              </a:ext>
+            </a:extLst>
+          </p:cNvPr>
+          <p:cNvPicPr>
+            <a:picLocks noChangeAspect="1"/>
+          </p:cNvPicPr>
+          <p:nvPr/>
+        </p:nvPicPr>
+        <p:blipFill>
+          <a:blip r:embed="rId2"/>
+          <a:stretch>
+            <a:fillRect/>
+          </a:stretch>
+        </p:blipFill>
+        <p:spPr>
+          <a:xfrm>
+            <a:off x="6607124" y="3655269"/>
+            <a:ext cx="5336037" cy="3001521"/>
+          </a:xfrm>
+          <a:prstGeom prst="rect">
+            <a:avLst/>
+          </a:prstGeom>
+        </p:spPr>
+      </p:pic>
     </p:spTree>
     <p:extLst>
       <p:ext uri="{BB962C8B-B14F-4D97-AF65-F5344CB8AC3E}">
@@ -3904,110 +4564,401 @@
             <p:ph type="title"/>
           </p:nvPr>
         </p:nvSpPr>
-        <p:spPr/>
+        <p:spPr>
+          <a:xfrm>
+            <a:off x="695464" y="200087"/>
+            <a:ext cx="10515600" cy="1325563"/>
+          </a:xfrm>
+        </p:spPr>
         <p:txBody>
           <a:bodyPr/>
           <a:lstStyle/>
           <a:p>
             <a:r>
               <a:rPr lang="en-GB" dirty="0"/>
-              <a:t>Experimental setup</a:t>
-            </a:r>
-          </a:p>
-        </p:txBody>
-      </p:sp>
-      <p:sp>
-        <p:nvSpPr>
-          <p:cNvPr id="3" name="Content Placeholder 2">
-            <a:extLst>
-              <a:ext uri="{FF2B5EF4-FFF2-40B4-BE49-F238E27FC236}">
-                <a16:creationId xmlns:a16="http://schemas.microsoft.com/office/drawing/2014/main" id="{A9CDFD70-B897-4A43-D1BE-A1240A25FBB3}"/>
-              </a:ext>
-            </a:extLst>
-          </p:cNvPr>
-          <p:cNvSpPr>
-            <a:spLocks noGrp="1"/>
-          </p:cNvSpPr>
-          <p:nvPr>
-            <p:ph idx="1"/>
-          </p:nvPr>
-        </p:nvSpPr>
-        <p:spPr/>
-        <p:txBody>
-          <a:bodyPr/>
-          <a:lstStyle/>
-          <a:p>
-            <a:r>
-              <a:rPr lang="en-GB" dirty="0"/>
-              <a:t>Aerodynamic performance in the form of an efficiency value</a:t>
-            </a:r>
-          </a:p>
-          <a:p>
-            <a:pPr marL="0" indent="0">
-              <a:buNone/>
-            </a:pPr>
-            <a:endParaRPr lang="en-GB" dirty="0"/>
-          </a:p>
-          <a:p>
-            <a:pPr marL="0" indent="0">
-              <a:buNone/>
-            </a:pPr>
-            <a:r>
-              <a:rPr lang="en-GB" dirty="0"/>
-              <a:t>Efficiency = </a:t>
-            </a:r>
-            <a:r>
-              <a:rPr lang="en-GB" dirty="0" err="1"/>
-              <a:t>C_thrust</a:t>
-            </a:r>
-            <a:r>
-              <a:rPr lang="en-GB" dirty="0"/>
-              <a:t> / </a:t>
-            </a:r>
-            <a:r>
-              <a:rPr lang="en-GB" dirty="0" err="1"/>
-              <a:t>C_power</a:t>
-            </a:r>
-            <a:endParaRPr lang="en-GB" dirty="0"/>
-          </a:p>
-          <a:p>
-            <a:pPr marL="0" indent="0">
-              <a:buNone/>
-            </a:pPr>
-            <a:endParaRPr lang="en-GB" dirty="0"/>
-          </a:p>
-          <a:p>
-            <a:pPr marL="0" indent="0">
-              <a:buNone/>
-            </a:pPr>
-            <a:r>
-              <a:rPr lang="en-GB" dirty="0"/>
-              <a:t>Power is calculated by angular speed * torque from moment of drag.</a:t>
-            </a:r>
-          </a:p>
-          <a:p>
-            <a:pPr marL="0" indent="0">
-              <a:buNone/>
-            </a:pPr>
-            <a:r>
-              <a:rPr lang="en-GB" dirty="0"/>
-              <a:t>Need to measure speed, torque, thrust</a:t>
-            </a:r>
-          </a:p>
-          <a:p>
-            <a:pPr marL="0" indent="0">
-              <a:buNone/>
-            </a:pPr>
-            <a:endParaRPr lang="en-GB" dirty="0"/>
-          </a:p>
-          <a:p>
-            <a:pPr marL="0" indent="0">
-              <a:buNone/>
-            </a:pPr>
-            <a:endParaRPr lang="en-GB" dirty="0"/>
-          </a:p>
-        </p:txBody>
-      </p:sp>
+              <a:t>Aerodynamic performance</a:t>
+            </a:r>
+          </a:p>
+        </p:txBody>
+      </p:sp>
+      <mc:AlternateContent xmlns:mc="http://schemas.openxmlformats.org/markup-compatibility/2006">
+        <mc:Choice xmlns:a14="http://schemas.microsoft.com/office/drawing/2010/main" Requires="a14">
+          <p:sp>
+            <p:nvSpPr>
+              <p:cNvPr id="3" name="Content Placeholder 2">
+                <a:extLst>
+                  <a:ext uri="{FF2B5EF4-FFF2-40B4-BE49-F238E27FC236}">
+                    <a16:creationId xmlns:a16="http://schemas.microsoft.com/office/drawing/2014/main" id="{A9CDFD70-B897-4A43-D1BE-A1240A25FBB3}"/>
+                  </a:ext>
+                </a:extLst>
+              </p:cNvPr>
+              <p:cNvSpPr>
+                <a:spLocks noGrp="1"/>
+              </p:cNvSpPr>
+              <p:nvPr>
+                <p:ph idx="1"/>
+              </p:nvPr>
+            </p:nvSpPr>
+            <p:spPr>
+              <a:xfrm>
+                <a:off x="838200" y="1633824"/>
+                <a:ext cx="10515600" cy="4860646"/>
+              </a:xfrm>
+            </p:spPr>
+            <p:txBody>
+              <a:bodyPr/>
+              <a:lstStyle/>
+              <a:p>
+                <a:r>
+                  <a:rPr lang="en-GB" dirty="0"/>
+                  <a:t>Aerodynamic performance quantities</a:t>
+                </a:r>
+              </a:p>
+              <a:p>
+                <a:endParaRPr lang="en-GB" dirty="0"/>
+              </a:p>
+              <a:p>
+                <a:pPr marL="0" indent="0">
+                  <a:buNone/>
+                </a:pPr>
+                <a14:m>
+                  <m:oMathPara xmlns:m="http://schemas.openxmlformats.org/officeDocument/2006/math">
+                    <m:oMathParaPr>
+                      <m:jc m:val="centerGroup"/>
+                    </m:oMathParaPr>
+                    <m:oMath xmlns:m="http://schemas.openxmlformats.org/officeDocument/2006/math">
+                      <m:sSub>
+                        <m:sSubPr>
+                          <m:ctrlPr>
+                            <a:rPr lang="en-GB" b="0" i="1" smtClean="0">
+                              <a:latin typeface="Cambria Math" panose="02040503050406030204" pitchFamily="18" charset="0"/>
+                            </a:rPr>
+                          </m:ctrlPr>
+                        </m:sSubPr>
+                        <m:e>
+                          <m:r>
+                            <a:rPr lang="en-GB" b="0" i="1" smtClean="0">
+                              <a:latin typeface="Cambria Math" panose="02040503050406030204" pitchFamily="18" charset="0"/>
+                            </a:rPr>
+                            <m:t>𝐶</m:t>
+                          </m:r>
+                        </m:e>
+                        <m:sub>
+                          <m:r>
+                            <a:rPr lang="en-GB" b="0" i="1" smtClean="0">
+                              <a:latin typeface="Cambria Math" panose="02040503050406030204" pitchFamily="18" charset="0"/>
+                            </a:rPr>
+                            <m:t>𝑇</m:t>
+                          </m:r>
+                        </m:sub>
+                      </m:sSub>
+                      <m:r>
+                        <a:rPr lang="en-GB" b="0" i="1" smtClean="0">
+                          <a:latin typeface="Cambria Math" panose="02040503050406030204" pitchFamily="18" charset="0"/>
+                        </a:rPr>
+                        <m:t>=</m:t>
+                      </m:r>
+                      <m:f>
+                        <m:fPr>
+                          <m:ctrlPr>
+                            <a:rPr lang="en-GB" b="0" i="1" smtClean="0">
+                              <a:latin typeface="Cambria Math" panose="02040503050406030204" pitchFamily="18" charset="0"/>
+                            </a:rPr>
+                          </m:ctrlPr>
+                        </m:fPr>
+                        <m:num>
+                          <m:r>
+                            <a:rPr lang="en-GB" b="0" i="1" smtClean="0">
+                              <a:latin typeface="Cambria Math" panose="02040503050406030204" pitchFamily="18" charset="0"/>
+                            </a:rPr>
+                            <m:t>𝑇</m:t>
+                          </m:r>
+                        </m:num>
+                        <m:den>
+                          <m:r>
+                            <a:rPr lang="en-GB" b="0" i="1" smtClean="0">
+                              <a:latin typeface="Cambria Math" panose="02040503050406030204" pitchFamily="18" charset="0"/>
+                            </a:rPr>
+                            <m:t>𝜌</m:t>
+                          </m:r>
+                          <m:sSup>
+                            <m:sSupPr>
+                              <m:ctrlPr>
+                                <a:rPr lang="en-GB" b="0" i="1" smtClean="0">
+                                  <a:latin typeface="Cambria Math" panose="02040503050406030204" pitchFamily="18" charset="0"/>
+                                </a:rPr>
+                              </m:ctrlPr>
+                            </m:sSupPr>
+                            <m:e>
+                              <m:r>
+                                <a:rPr lang="en-GB" b="0" i="1" smtClean="0">
+                                  <a:latin typeface="Cambria Math" panose="02040503050406030204" pitchFamily="18" charset="0"/>
+                                </a:rPr>
+                                <m:t>𝑁</m:t>
+                              </m:r>
+                            </m:e>
+                            <m:sup>
+                              <m:r>
+                                <a:rPr lang="en-GB" b="0" i="1" smtClean="0">
+                                  <a:latin typeface="Cambria Math" panose="02040503050406030204" pitchFamily="18" charset="0"/>
+                                </a:rPr>
+                                <m:t>2</m:t>
+                              </m:r>
+                            </m:sup>
+                          </m:sSup>
+                          <m:sSup>
+                            <m:sSupPr>
+                              <m:ctrlPr>
+                                <a:rPr lang="en-GB" b="0" i="1" smtClean="0">
+                                  <a:latin typeface="Cambria Math" panose="02040503050406030204" pitchFamily="18" charset="0"/>
+                                </a:rPr>
+                              </m:ctrlPr>
+                            </m:sSupPr>
+                            <m:e>
+                              <m:r>
+                                <a:rPr lang="en-GB" b="0" i="1" smtClean="0">
+                                  <a:latin typeface="Cambria Math" panose="02040503050406030204" pitchFamily="18" charset="0"/>
+                                </a:rPr>
+                                <m:t>𝐷</m:t>
+                              </m:r>
+                            </m:e>
+                            <m:sup>
+                              <m:r>
+                                <a:rPr lang="en-GB" b="0" i="1" smtClean="0">
+                                  <a:latin typeface="Cambria Math" panose="02040503050406030204" pitchFamily="18" charset="0"/>
+                                </a:rPr>
+                                <m:t>4</m:t>
+                              </m:r>
+                            </m:sup>
+                          </m:sSup>
+                        </m:den>
+                      </m:f>
+                      <m:r>
+                        <a:rPr lang="en-GB" b="0" i="1" smtClean="0">
+                          <a:latin typeface="Cambria Math" panose="02040503050406030204" pitchFamily="18" charset="0"/>
+                        </a:rPr>
+                        <m:t>, </m:t>
+                      </m:r>
+                      <m:sSub>
+                        <m:sSubPr>
+                          <m:ctrlPr>
+                            <a:rPr lang="en-GB" b="0" i="1" smtClean="0">
+                              <a:latin typeface="Cambria Math" panose="02040503050406030204" pitchFamily="18" charset="0"/>
+                            </a:rPr>
+                          </m:ctrlPr>
+                        </m:sSubPr>
+                        <m:e>
+                          <m:r>
+                            <a:rPr lang="en-GB" b="0" i="1" smtClean="0">
+                              <a:latin typeface="Cambria Math" panose="02040503050406030204" pitchFamily="18" charset="0"/>
+                            </a:rPr>
+                            <m:t>𝐶</m:t>
+                          </m:r>
+                        </m:e>
+                        <m:sub>
+                          <m:r>
+                            <a:rPr lang="en-GB" b="0" i="1" smtClean="0">
+                              <a:latin typeface="Cambria Math" panose="02040503050406030204" pitchFamily="18" charset="0"/>
+                            </a:rPr>
+                            <m:t>𝑃</m:t>
+                          </m:r>
+                        </m:sub>
+                      </m:sSub>
+                      <m:r>
+                        <a:rPr lang="en-GB" b="0" i="1" smtClean="0">
+                          <a:latin typeface="Cambria Math" panose="02040503050406030204" pitchFamily="18" charset="0"/>
+                        </a:rPr>
+                        <m:t>=</m:t>
+                      </m:r>
+                      <m:f>
+                        <m:fPr>
+                          <m:ctrlPr>
+                            <a:rPr lang="en-GB" b="0" i="1" smtClean="0">
+                              <a:latin typeface="Cambria Math" panose="02040503050406030204" pitchFamily="18" charset="0"/>
+                            </a:rPr>
+                          </m:ctrlPr>
+                        </m:fPr>
+                        <m:num>
+                          <m:r>
+                            <a:rPr lang="en-GB" b="0" i="1" smtClean="0">
+                              <a:latin typeface="Cambria Math" panose="02040503050406030204" pitchFamily="18" charset="0"/>
+                            </a:rPr>
+                            <m:t>𝑃</m:t>
+                          </m:r>
+                        </m:num>
+                        <m:den>
+                          <m:r>
+                            <a:rPr lang="en-GB" b="0" i="1" smtClean="0">
+                              <a:latin typeface="Cambria Math" panose="02040503050406030204" pitchFamily="18" charset="0"/>
+                            </a:rPr>
+                            <m:t>𝜌</m:t>
+                          </m:r>
+                          <m:sSup>
+                            <m:sSupPr>
+                              <m:ctrlPr>
+                                <a:rPr lang="en-GB" b="0" i="1" smtClean="0">
+                                  <a:latin typeface="Cambria Math" panose="02040503050406030204" pitchFamily="18" charset="0"/>
+                                </a:rPr>
+                              </m:ctrlPr>
+                            </m:sSupPr>
+                            <m:e>
+                              <m:r>
+                                <a:rPr lang="en-GB" b="0" i="1" smtClean="0">
+                                  <a:latin typeface="Cambria Math" panose="02040503050406030204" pitchFamily="18" charset="0"/>
+                                </a:rPr>
+                                <m:t>𝑁</m:t>
+                              </m:r>
+                            </m:e>
+                            <m:sup>
+                              <m:r>
+                                <a:rPr lang="en-GB" b="0" i="1" smtClean="0">
+                                  <a:latin typeface="Cambria Math" panose="02040503050406030204" pitchFamily="18" charset="0"/>
+                                </a:rPr>
+                                <m:t>3</m:t>
+                              </m:r>
+                            </m:sup>
+                          </m:sSup>
+                          <m:sSup>
+                            <m:sSupPr>
+                              <m:ctrlPr>
+                                <a:rPr lang="en-GB" b="0" i="1" smtClean="0">
+                                  <a:latin typeface="Cambria Math" panose="02040503050406030204" pitchFamily="18" charset="0"/>
+                                </a:rPr>
+                              </m:ctrlPr>
+                            </m:sSupPr>
+                            <m:e>
+                              <m:r>
+                                <a:rPr lang="en-GB" b="0" i="1" smtClean="0">
+                                  <a:latin typeface="Cambria Math" panose="02040503050406030204" pitchFamily="18" charset="0"/>
+                                </a:rPr>
+                                <m:t>𝐷</m:t>
+                              </m:r>
+                            </m:e>
+                            <m:sup>
+                              <m:r>
+                                <a:rPr lang="en-GB" b="0" i="1" smtClean="0">
+                                  <a:latin typeface="Cambria Math" panose="02040503050406030204" pitchFamily="18" charset="0"/>
+                                </a:rPr>
+                                <m:t>5</m:t>
+                              </m:r>
+                            </m:sup>
+                          </m:sSup>
+                        </m:den>
+                      </m:f>
+                    </m:oMath>
+                  </m:oMathPara>
+                </a14:m>
+                <a:endParaRPr lang="en-GB" dirty="0"/>
+              </a:p>
+              <a:p>
+                <a:pPr marL="0" indent="0">
+                  <a:buNone/>
+                </a:pPr>
+                <a:endParaRPr lang="en-GB" dirty="0"/>
+              </a:p>
+              <a:p>
+                <a:pPr marL="0" indent="0">
+                  <a:buNone/>
+                </a:pPr>
+                <a:r>
+                  <a:rPr lang="en-GB" dirty="0"/>
+                  <a:t>Power is obtained from </a:t>
+                </a:r>
+                <a14:m>
+                  <m:oMath xmlns:m="http://schemas.openxmlformats.org/officeDocument/2006/math">
+                    <m:r>
+                      <a:rPr lang="en-GB" b="0" i="1" smtClean="0">
+                        <a:latin typeface="Cambria Math" panose="02040503050406030204" pitchFamily="18" charset="0"/>
+                      </a:rPr>
+                      <m:t>𝜏</m:t>
+                    </m:r>
+                    <m:r>
+                      <a:rPr lang="en-GB" b="0" i="1" smtClean="0">
+                        <a:latin typeface="Cambria Math" panose="02040503050406030204" pitchFamily="18" charset="0"/>
+                      </a:rPr>
+                      <m:t>⋅2</m:t>
+                    </m:r>
+                    <m:r>
+                      <a:rPr lang="en-GB" b="0" i="1" smtClean="0">
+                        <a:latin typeface="Cambria Math" panose="02040503050406030204" pitchFamily="18" charset="0"/>
+                      </a:rPr>
+                      <m:t>𝜋</m:t>
+                    </m:r>
+                    <m:r>
+                      <a:rPr lang="en-GB" b="0" i="1" smtClean="0">
+                        <a:latin typeface="Cambria Math" panose="02040503050406030204" pitchFamily="18" charset="0"/>
+                      </a:rPr>
+                      <m:t>𝑁</m:t>
+                    </m:r>
+                  </m:oMath>
+                </a14:m>
+                <a:r>
+                  <a:rPr lang="en-GB" dirty="0"/>
+                  <a:t> </a:t>
+                </a:r>
+              </a:p>
+              <a:p>
+                <a:pPr marL="0" indent="0">
+                  <a:buNone/>
+                </a:pPr>
+                <a:endParaRPr lang="en-GB" dirty="0"/>
+              </a:p>
+              <a:p>
+                <a:pPr marL="0" indent="0">
+                  <a:buNone/>
+                </a:pPr>
+                <a:r>
+                  <a:rPr lang="en-GB" dirty="0"/>
+                  <a:t>Require values for torque, thrust and angular speed.</a:t>
+                </a:r>
+              </a:p>
+            </p:txBody>
+          </p:sp>
+        </mc:Choice>
+        <mc:Fallback>
+          <p:sp>
+            <p:nvSpPr>
+              <p:cNvPr id="3" name="Content Placeholder 2">
+                <a:extLst>
+                  <a:ext uri="{FF2B5EF4-FFF2-40B4-BE49-F238E27FC236}">
+                    <a16:creationId xmlns:a16="http://schemas.microsoft.com/office/drawing/2014/main" id="{A9CDFD70-B897-4A43-D1BE-A1240A25FBB3}"/>
+                  </a:ext>
+                </a:extLst>
+              </p:cNvPr>
+              <p:cNvSpPr>
+                <a:spLocks noGrp="1" noRot="1" noChangeAspect="1" noMove="1" noResize="1" noEditPoints="1" noAdjustHandles="1" noChangeArrowheads="1" noChangeShapeType="1" noTextEdit="1"/>
+              </p:cNvSpPr>
+              <p:nvPr>
+                <p:ph idx="1"/>
+              </p:nvPr>
+            </p:nvSpPr>
+            <p:spPr>
+              <a:xfrm>
+                <a:off x="838200" y="1633824"/>
+                <a:ext cx="10515600" cy="4860646"/>
+              </a:xfrm>
+              <a:blipFill>
+                <a:blip r:embed="rId3"/>
+                <a:stretch>
+                  <a:fillRect l="-1217" t="-2133"/>
+                </a:stretch>
+              </a:blipFill>
+            </p:spPr>
+            <p:txBody>
+              <a:bodyPr/>
+              <a:lstStyle/>
+              <a:p>
+                <a:r>
+                  <a:rPr lang="en-GB">
+                    <a:noFill/>
+                  </a:rPr>
+                  <a:t> </a:t>
+                </a:r>
+              </a:p>
+            </p:txBody>
+          </p:sp>
+        </mc:Fallback>
+      </mc:AlternateContent>
     </p:spTree>
     <p:extLst>
       <p:ext uri="{BB962C8B-B14F-4D97-AF65-F5344CB8AC3E}">
@@ -4043,6 +4994,301 @@
           <p:cNvPr id="2" name="Title 1">
             <a:extLst>
               <a:ext uri="{FF2B5EF4-FFF2-40B4-BE49-F238E27FC236}">
+                <a16:creationId xmlns:a16="http://schemas.microsoft.com/office/drawing/2014/main" id="{DD1D9AC5-0EC4-38D7-8E7D-41944460A213}"/>
+              </a:ext>
+            </a:extLst>
+          </p:cNvPr>
+          <p:cNvSpPr>
+            <a:spLocks noGrp="1"/>
+          </p:cNvSpPr>
+          <p:nvPr>
+            <p:ph type="title"/>
+          </p:nvPr>
+        </p:nvSpPr>
+        <p:spPr>
+          <a:xfrm>
+            <a:off x="614570" y="231946"/>
+            <a:ext cx="10515600" cy="1325563"/>
+          </a:xfrm>
+        </p:spPr>
+        <p:txBody>
+          <a:bodyPr/>
+          <a:lstStyle/>
+          <a:p>
+            <a:r>
+              <a:rPr lang="en-GB" dirty="0"/>
+              <a:t>Aerodynamic measurements</a:t>
+            </a:r>
+          </a:p>
+        </p:txBody>
+      </p:sp>
+      <p:sp>
+        <p:nvSpPr>
+          <p:cNvPr id="3" name="Content Placeholder 2">
+            <a:extLst>
+              <a:ext uri="{FF2B5EF4-FFF2-40B4-BE49-F238E27FC236}">
+                <a16:creationId xmlns:a16="http://schemas.microsoft.com/office/drawing/2014/main" id="{9C7375A3-69B7-413F-69EC-A8BA51B8A28B}"/>
+              </a:ext>
+            </a:extLst>
+          </p:cNvPr>
+          <p:cNvSpPr>
+            <a:spLocks noGrp="1"/>
+          </p:cNvSpPr>
+          <p:nvPr>
+            <p:ph idx="1"/>
+          </p:nvPr>
+        </p:nvSpPr>
+        <p:spPr>
+          <a:xfrm>
+            <a:off x="569845" y="1756051"/>
+            <a:ext cx="5304181" cy="4629840"/>
+          </a:xfrm>
+        </p:spPr>
+        <p:txBody>
+          <a:bodyPr>
+            <a:normAutofit/>
+          </a:bodyPr>
+          <a:lstStyle/>
+          <a:p>
+            <a:pPr marL="0" indent="0">
+              <a:buNone/>
+            </a:pPr>
+            <a:r>
+              <a:rPr lang="en-GB" dirty="0"/>
+              <a:t>Torque and thrust measured by strain gauge load cells</a:t>
+            </a:r>
+          </a:p>
+          <a:p>
+            <a:pPr marL="0" indent="0">
+              <a:buNone/>
+            </a:pPr>
+            <a:endParaRPr lang="en-GB" dirty="0"/>
+          </a:p>
+          <a:p>
+            <a:pPr marL="0" indent="0">
+              <a:buNone/>
+            </a:pPr>
+            <a:r>
+              <a:rPr lang="en-GB" dirty="0"/>
+              <a:t>Full bridge cantilever models selected for sensitivity and resistance to off-axis forces</a:t>
+            </a:r>
+          </a:p>
+          <a:p>
+            <a:pPr marL="0" indent="0">
+              <a:buNone/>
+            </a:pPr>
+            <a:endParaRPr lang="en-GB" dirty="0"/>
+          </a:p>
+          <a:p>
+            <a:pPr marL="0" indent="0">
+              <a:buNone/>
+            </a:pPr>
+            <a:r>
+              <a:rPr lang="en-GB" dirty="0"/>
+              <a:t>Orientation selected for accuracy, and ease of calibration</a:t>
+            </a:r>
+          </a:p>
+        </p:txBody>
+      </p:sp>
+      <p:sp>
+        <p:nvSpPr>
+          <p:cNvPr id="7" name="Rectangle 6">
+            <a:extLst>
+              <a:ext uri="{FF2B5EF4-FFF2-40B4-BE49-F238E27FC236}">
+                <a16:creationId xmlns:a16="http://schemas.microsoft.com/office/drawing/2014/main" id="{CA5045A9-E972-F760-9683-4A4D6E4619BE}"/>
+              </a:ext>
+            </a:extLst>
+          </p:cNvPr>
+          <p:cNvSpPr/>
+          <p:nvPr/>
+        </p:nvSpPr>
+        <p:spPr>
+          <a:xfrm>
+            <a:off x="6157291" y="1232452"/>
+            <a:ext cx="5680213" cy="5317435"/>
+          </a:xfrm>
+          <a:prstGeom prst="rect">
+            <a:avLst/>
+          </a:prstGeom>
+        </p:spPr>
+        <p:style>
+          <a:lnRef idx="2">
+            <a:schemeClr val="accent1">
+              <a:shade val="15000"/>
+            </a:schemeClr>
+          </a:lnRef>
+          <a:fillRef idx="1">
+            <a:schemeClr val="accent1"/>
+          </a:fillRef>
+          <a:effectRef idx="0">
+            <a:schemeClr val="accent1"/>
+          </a:effectRef>
+          <a:fontRef idx="minor">
+            <a:schemeClr val="lt1"/>
+          </a:fontRef>
+        </p:style>
+        <p:txBody>
+          <a:bodyPr rtlCol="0" anchor="ctr"/>
+          <a:lstStyle/>
+          <a:p>
+            <a:pPr algn="ctr"/>
+            <a:r>
+              <a:rPr lang="en-GB" dirty="0"/>
+              <a:t>CAD</a:t>
+            </a:r>
+          </a:p>
+        </p:txBody>
+      </p:sp>
+    </p:spTree>
+    <p:extLst>
+      <p:ext uri="{BB962C8B-B14F-4D97-AF65-F5344CB8AC3E}">
+        <p14:creationId xmlns:p14="http://schemas.microsoft.com/office/powerpoint/2010/main" val="2695031417"/>
+      </p:ext>
+    </p:extLst>
+  </p:cSld>
+  <p:clrMapOvr>
+    <a:masterClrMapping/>
+  </p:clrMapOvr>
+</p:sld>
+</file>
+
+<file path=ppt/slides/slide8.xml><?xml version="1.0" encoding="utf-8"?>
+<p:sld xmlns:a="http://schemas.openxmlformats.org/drawingml/2006/main" xmlns:r="http://schemas.openxmlformats.org/officeDocument/2006/relationships" xmlns:p="http://schemas.openxmlformats.org/presentationml/2006/main">
+  <p:cSld>
+    <p:spTree>
+      <p:nvGrpSpPr>
+        <p:cNvPr id="1" name=""/>
+        <p:cNvGrpSpPr/>
+        <p:nvPr/>
+      </p:nvGrpSpPr>
+      <p:grpSpPr>
+        <a:xfrm>
+          <a:off x="0" y="0"/>
+          <a:ext cx="0" cy="0"/>
+          <a:chOff x="0" y="0"/>
+          <a:chExt cx="0" cy="0"/>
+        </a:xfrm>
+      </p:grpSpPr>
+      <p:sp>
+        <p:nvSpPr>
+          <p:cNvPr id="2" name="Title 1">
+            <a:extLst>
+              <a:ext uri="{FF2B5EF4-FFF2-40B4-BE49-F238E27FC236}">
+                <a16:creationId xmlns:a16="http://schemas.microsoft.com/office/drawing/2014/main" id="{92553C29-8BE0-FA3F-BADF-EB4F5C5E7059}"/>
+              </a:ext>
+            </a:extLst>
+          </p:cNvPr>
+          <p:cNvSpPr>
+            <a:spLocks noGrp="1"/>
+          </p:cNvSpPr>
+          <p:nvPr>
+            <p:ph type="title"/>
+          </p:nvPr>
+        </p:nvSpPr>
+        <p:spPr/>
+        <p:txBody>
+          <a:bodyPr/>
+          <a:lstStyle/>
+          <a:p>
+            <a:r>
+              <a:rPr lang="en-GB" dirty="0"/>
+              <a:t>Acoustic performance</a:t>
+            </a:r>
+          </a:p>
+        </p:txBody>
+      </p:sp>
+      <p:sp>
+        <p:nvSpPr>
+          <p:cNvPr id="3" name="Content Placeholder 2">
+            <a:extLst>
+              <a:ext uri="{FF2B5EF4-FFF2-40B4-BE49-F238E27FC236}">
+                <a16:creationId xmlns:a16="http://schemas.microsoft.com/office/drawing/2014/main" id="{5C5C9FEE-F51C-BBC5-5750-D5F85AFD1F9B}"/>
+              </a:ext>
+            </a:extLst>
+          </p:cNvPr>
+          <p:cNvSpPr>
+            <a:spLocks noGrp="1"/>
+          </p:cNvSpPr>
+          <p:nvPr>
+            <p:ph idx="1"/>
+          </p:nvPr>
+        </p:nvSpPr>
+        <p:spPr/>
+        <p:txBody>
+          <a:bodyPr>
+            <a:normAutofit/>
+          </a:bodyPr>
+          <a:lstStyle/>
+          <a:p>
+            <a:pPr marL="0" indent="0">
+              <a:buNone/>
+            </a:pPr>
+            <a:r>
+              <a:rPr lang="en-GB" dirty="0"/>
+              <a:t>To quantify the annoyance of sound the psychoacoustics must be considered</a:t>
+            </a:r>
+          </a:p>
+          <a:p>
+            <a:pPr marL="0" indent="0">
+              <a:buNone/>
+            </a:pPr>
+            <a:endParaRPr lang="en-GB" dirty="0"/>
+          </a:p>
+          <a:p>
+            <a:pPr marL="0" indent="0">
+              <a:buNone/>
+            </a:pPr>
+            <a:r>
+              <a:rPr lang="en-GB" dirty="0"/>
+              <a:t>P</a:t>
+            </a:r>
+            <a:r>
+              <a:rPr lang="en-US" dirty="0" err="1"/>
+              <a:t>sychoacoustic</a:t>
+            </a:r>
+            <a:r>
+              <a:rPr lang="en-US" dirty="0"/>
+              <a:t> metrics of loudness, fluctuation strength, roughness, sharpness, tonality</a:t>
+            </a:r>
+            <a:endParaRPr lang="en-GB" dirty="0"/>
+          </a:p>
+        </p:txBody>
+      </p:sp>
+    </p:spTree>
+    <p:extLst>
+      <p:ext uri="{BB962C8B-B14F-4D97-AF65-F5344CB8AC3E}">
+        <p14:creationId xmlns:p14="http://schemas.microsoft.com/office/powerpoint/2010/main" val="1354065674"/>
+      </p:ext>
+    </p:extLst>
+  </p:cSld>
+  <p:clrMapOvr>
+    <a:masterClrMapping/>
+  </p:clrMapOvr>
+</p:sld>
+</file>
+
+<file path=ppt/slides/slide9.xml><?xml version="1.0" encoding="utf-8"?>
+<p:sld xmlns:a="http://schemas.openxmlformats.org/drawingml/2006/main" xmlns:r="http://schemas.openxmlformats.org/officeDocument/2006/relationships" xmlns:p="http://schemas.openxmlformats.org/presentationml/2006/main">
+  <p:cSld>
+    <p:spTree>
+      <p:nvGrpSpPr>
+        <p:cNvPr id="1" name=""/>
+        <p:cNvGrpSpPr/>
+        <p:nvPr/>
+      </p:nvGrpSpPr>
+      <p:grpSpPr>
+        <a:xfrm>
+          <a:off x="0" y="0"/>
+          <a:ext cx="0" cy="0"/>
+          <a:chOff x="0" y="0"/>
+          <a:chExt cx="0" cy="0"/>
+        </a:xfrm>
+      </p:grpSpPr>
+      <p:sp>
+        <p:nvSpPr>
+          <p:cNvPr id="2" name="Title 1">
+            <a:extLst>
+              <a:ext uri="{FF2B5EF4-FFF2-40B4-BE49-F238E27FC236}">
                 <a16:creationId xmlns:a16="http://schemas.microsoft.com/office/drawing/2014/main" id="{1EBECBE2-A4C4-70B6-C758-B1BD9EEA99FE}"/>
               </a:ext>
             </a:extLst>
@@ -4054,37 +5300,115 @@
             <p:ph type="title"/>
           </p:nvPr>
         </p:nvSpPr>
-        <p:spPr/>
-        <p:txBody>
-          <a:bodyPr/>
-          <a:lstStyle/>
-          <a:p>
-            <a:endParaRPr lang="en-GB"/>
-          </a:p>
-        </p:txBody>
-      </p:sp>
-      <p:sp>
-        <p:nvSpPr>
-          <p:cNvPr id="3" name="Content Placeholder 2">
-            <a:extLst>
-              <a:ext uri="{FF2B5EF4-FFF2-40B4-BE49-F238E27FC236}">
-                <a16:creationId xmlns:a16="http://schemas.microsoft.com/office/drawing/2014/main" id="{FDADD7C6-C812-D98F-82FE-5FE4081FFFD0}"/>
-              </a:ext>
-            </a:extLst>
-          </p:cNvPr>
-          <p:cNvSpPr>
-            <a:spLocks noGrp="1"/>
-          </p:cNvSpPr>
-          <p:nvPr>
-            <p:ph idx="1"/>
-          </p:nvPr>
-        </p:nvSpPr>
-        <p:spPr/>
-        <p:txBody>
-          <a:bodyPr/>
-          <a:lstStyle/>
-          <a:p>
-            <a:endParaRPr lang="en-GB"/>
+        <p:spPr>
+          <a:xfrm>
+            <a:off x="753451" y="249153"/>
+            <a:ext cx="10515600" cy="1325563"/>
+          </a:xfrm>
+        </p:spPr>
+        <p:txBody>
+          <a:bodyPr/>
+          <a:lstStyle/>
+          <a:p>
+            <a:r>
+              <a:rPr lang="en-GB" dirty="0"/>
+              <a:t>Questions?</a:t>
+            </a:r>
+          </a:p>
+        </p:txBody>
+      </p:sp>
+      <p:sp>
+        <p:nvSpPr>
+          <p:cNvPr id="5" name="TextBox 4">
+            <a:extLst>
+              <a:ext uri="{FF2B5EF4-FFF2-40B4-BE49-F238E27FC236}">
+                <a16:creationId xmlns:a16="http://schemas.microsoft.com/office/drawing/2014/main" id="{E44BC597-3E26-981B-2200-703284AC4B74}"/>
+              </a:ext>
+            </a:extLst>
+          </p:cNvPr>
+          <p:cNvSpPr txBox="1"/>
+          <p:nvPr/>
+        </p:nvSpPr>
+        <p:spPr>
+          <a:xfrm>
+            <a:off x="922949" y="4398395"/>
+            <a:ext cx="6095256" cy="646331"/>
+          </a:xfrm>
+          <a:prstGeom prst="rect">
+            <a:avLst/>
+          </a:prstGeom>
+          <a:noFill/>
+        </p:spPr>
+        <p:txBody>
+          <a:bodyPr wrap="square">
+            <a:spAutoFit/>
+          </a:bodyPr>
+          <a:lstStyle/>
+          <a:p>
+            <a:r>
+              <a:rPr lang="en-GB" dirty="0"/>
+              <a:t>Toroidal propeller designs – Thingyverse </a:t>
+            </a:r>
+          </a:p>
+          <a:p>
+            <a:r>
+              <a:rPr lang="en-GB" dirty="0"/>
+              <a:t>Owl image – Wang and Liu</a:t>
+            </a:r>
+          </a:p>
+        </p:txBody>
+      </p:sp>
+      <p:sp>
+        <p:nvSpPr>
+          <p:cNvPr id="6" name="Title 1">
+            <a:extLst>
+              <a:ext uri="{FF2B5EF4-FFF2-40B4-BE49-F238E27FC236}">
+                <a16:creationId xmlns:a16="http://schemas.microsoft.com/office/drawing/2014/main" id="{B2EDC919-4D0D-9CAF-829E-6BC52F9E82E6}"/>
+              </a:ext>
+            </a:extLst>
+          </p:cNvPr>
+          <p:cNvSpPr txBox="1">
+            <a:spLocks/>
+          </p:cNvSpPr>
+          <p:nvPr/>
+        </p:nvSpPr>
+        <p:spPr>
+          <a:xfrm>
+            <a:off x="753451" y="3072832"/>
+            <a:ext cx="10515600" cy="1325563"/>
+          </a:xfrm>
+          <a:prstGeom prst="rect">
+            <a:avLst/>
+          </a:prstGeom>
+        </p:spPr>
+        <p:txBody>
+          <a:bodyPr vert="horz" lIns="91440" tIns="45720" rIns="91440" bIns="45720" rtlCol="0" anchor="ctr">
+            <a:normAutofit/>
+          </a:bodyPr>
+          <a:lstStyle>
+            <a:lvl1pPr algn="l" defTabSz="914400" rtl="0" eaLnBrk="1" latinLnBrk="0" hangingPunct="1">
+              <a:lnSpc>
+                <a:spcPct val="90000"/>
+              </a:lnSpc>
+              <a:spcBef>
+                <a:spcPct val="0"/>
+              </a:spcBef>
+              <a:buNone/>
+              <a:defRPr sz="4400" kern="1200">
+                <a:solidFill>
+                  <a:schemeClr val="tx1"/>
+                </a:solidFill>
+                <a:latin typeface="+mj-lt"/>
+                <a:ea typeface="+mj-ea"/>
+                <a:cs typeface="+mj-cs"/>
+              </a:defRPr>
+            </a:lvl1pPr>
+          </a:lstStyle>
+          <a:p>
+            <a:r>
+              <a:rPr lang="en-GB" dirty="0"/>
+              <a:t>References</a:t>
+            </a:r>
           </a:p>
         </p:txBody>
       </p:sp>
@@ -4414,4 +5738,319 @@
     </a:ext>
   </a:extLst>
 </a:theme>
+</file>
+
+<file path=ppt/theme/theme2.xml><?xml version="1.0" encoding="utf-8"?>
+<a:theme xmlns:a="http://schemas.openxmlformats.org/drawingml/2006/main" name="Office Theme">
+  <a:themeElements>
+    <a:clrScheme name="Office">
+      <a:dk1>
+        <a:sysClr val="windowText" lastClr="000000"/>
+      </a:dk1>
+      <a:lt1>
+        <a:sysClr val="window" lastClr="FFFFFF"/>
+      </a:lt1>
+      <a:dk2>
+        <a:srgbClr val="0E2841"/>
+      </a:dk2>
+      <a:lt2>
+        <a:srgbClr val="E8E8E8"/>
+      </a:lt2>
+      <a:accent1>
+        <a:srgbClr val="156082"/>
+      </a:accent1>
+      <a:accent2>
+        <a:srgbClr val="E97132"/>
+      </a:accent2>
+      <a:accent3>
+        <a:srgbClr val="196B24"/>
+      </a:accent3>
+      <a:accent4>
+        <a:srgbClr val="0F9ED5"/>
+      </a:accent4>
+      <a:accent5>
+        <a:srgbClr val="A02B93"/>
+      </a:accent5>
+      <a:accent6>
+        <a:srgbClr val="4EA72E"/>
+      </a:accent6>
+      <a:hlink>
+        <a:srgbClr val="467886"/>
+      </a:hlink>
+      <a:folHlink>
+        <a:srgbClr val="96607D"/>
+      </a:folHlink>
+    </a:clrScheme>
+    <a:fontScheme name="Office">
+      <a:majorFont>
+        <a:latin typeface="Aptos Display" panose="02110004020202020204"/>
+        <a:ea typeface=""/>
+        <a:cs typeface=""/>
+        <a:font script="Jpan" typeface="游ゴシック Light"/>
+        <a:font script="Hang" typeface="맑은 고딕"/>
+        <a:font script="Hans" typeface="等线 Light"/>
+        <a:font script="Hant" typeface="新細明體"/>
+        <a:font script="Arab" typeface="Times New Roman"/>
+        <a:font script="Hebr" typeface="Times New Roman"/>
+        <a:font script="Thai" typeface="Angsana New"/>
+        <a:font script="Ethi" typeface="Nyala"/>
+        <a:font script="Beng" typeface="Vrinda"/>
+        <a:font script="Gujr" typeface="Shruti"/>
+        <a:font script="Khmr" typeface="MoolBoran"/>
+        <a:font script="Knda" typeface="Tunga"/>
+        <a:font script="Guru" typeface="Raavi"/>
+        <a:font script="Cans" typeface="Euphemia"/>
+        <a:font script="Cher" typeface="Plantagenet Cherokee"/>
+        <a:font script="Yiii" typeface="Microsoft Yi Baiti"/>
+        <a:font script="Tibt" typeface="Microsoft Himalaya"/>
+        <a:font script="Thaa" typeface="MV Boli"/>
+        <a:font script="Deva" typeface="Mangal"/>
+        <a:font script="Telu" typeface="Gautami"/>
+        <a:font script="Taml" typeface="Latha"/>
+        <a:font script="Syrc" typeface="Estrangelo Edessa"/>
+        <a:font script="Orya" typeface="Kalinga"/>
+        <a:font script="Mlym" typeface="Kartika"/>
+        <a:font script="Laoo" typeface="DokChampa"/>
+        <a:font script="Sinh" typeface="Iskoola Pota"/>
+        <a:font script="Mong" typeface="Mongolian Baiti"/>
+        <a:font script="Viet" typeface="Times New Roman"/>
+        <a:font script="Uigh" typeface="Microsoft Uighur"/>
+        <a:font script="Geor" typeface="Sylfaen"/>
+        <a:font script="Armn" typeface="Arial"/>
+        <a:font script="Bugi" typeface="Leelawadee UI"/>
+        <a:font script="Bopo" typeface="Microsoft JhengHei"/>
+        <a:font script="Java" typeface="Javanese Text"/>
+        <a:font script="Lisu" typeface="Segoe UI"/>
+        <a:font script="Mymr" typeface="Myanmar Text"/>
+        <a:font script="Nkoo" typeface="Ebrima"/>
+        <a:font script="Olck" typeface="Nirmala UI"/>
+        <a:font script="Osma" typeface="Ebrima"/>
+        <a:font script="Phag" typeface="Phagspa"/>
+        <a:font script="Syrn" typeface="Estrangelo Edessa"/>
+        <a:font script="Syrj" typeface="Estrangelo Edessa"/>
+        <a:font script="Syre" typeface="Estrangelo Edessa"/>
+        <a:font script="Sora" typeface="Nirmala UI"/>
+        <a:font script="Tale" typeface="Microsoft Tai Le"/>
+        <a:font script="Talu" typeface="Microsoft New Tai Lue"/>
+        <a:font script="Tfng" typeface="Ebrima"/>
+      </a:majorFont>
+      <a:minorFont>
+        <a:latin typeface="Aptos" panose="02110004020202020204"/>
+        <a:ea typeface=""/>
+        <a:cs typeface=""/>
+        <a:font script="Jpan" typeface="游ゴシック"/>
+        <a:font script="Hang" typeface="맑은 고딕"/>
+        <a:font script="Hans" typeface="等线"/>
+        <a:font script="Hant" typeface="新細明體"/>
+        <a:font script="Arab" typeface="Arial"/>
+        <a:font script="Hebr" typeface="Arial"/>
+        <a:font script="Thai" typeface="Cordia New"/>
+        <a:font script="Ethi" typeface="Nyala"/>
+        <a:font script="Beng" typeface="Vrinda"/>
+        <a:font script="Gujr" typeface="Shruti"/>
+        <a:font script="Khmr" typeface="DaunPenh"/>
+        <a:font script="Knda" typeface="Tunga"/>
+        <a:font script="Guru" typeface="Raavi"/>
+        <a:font script="Cans" typeface="Euphemia"/>
+        <a:font script="Cher" typeface="Plantagenet Cherokee"/>
+        <a:font script="Yiii" typeface="Microsoft Yi Baiti"/>
+        <a:font script="Tibt" typeface="Microsoft Himalaya"/>
+        <a:font script="Thaa" typeface="MV Boli"/>
+        <a:font script="Deva" typeface="Mangal"/>
+        <a:font script="Telu" typeface="Gautami"/>
+        <a:font script="Taml" typeface="Latha"/>
+        <a:font script="Syrc" typeface="Estrangelo Edessa"/>
+        <a:font script="Orya" typeface="Kalinga"/>
+        <a:font script="Mlym" typeface="Kartika"/>
+        <a:font script="Laoo" typeface="DokChampa"/>
+        <a:font script="Sinh" typeface="Iskoola Pota"/>
+        <a:font script="Mong" typeface="Mongolian Baiti"/>
+        <a:font script="Viet" typeface="Arial"/>
+        <a:font script="Uigh" typeface="Microsoft Uighur"/>
+        <a:font script="Geor" typeface="Sylfaen"/>
+        <a:font script="Armn" typeface="Arial"/>
+        <a:font script="Bugi" typeface="Leelawadee UI"/>
+        <a:font script="Bopo" typeface="Microsoft JhengHei"/>
+        <a:font script="Java" typeface="Javanese Text"/>
+        <a:font script="Lisu" typeface="Segoe UI"/>
+        <a:font script="Mymr" typeface="Myanmar Text"/>
+        <a:font script="Nkoo" typeface="Ebrima"/>
+        <a:font script="Olck" typeface="Nirmala UI"/>
+        <a:font script="Osma" typeface="Ebrima"/>
+        <a:font script="Phag" typeface="Phagspa"/>
+        <a:font script="Syrn" typeface="Estrangelo Edessa"/>
+        <a:font script="Syrj" typeface="Estrangelo Edessa"/>
+        <a:font script="Syre" typeface="Estrangelo Edessa"/>
+        <a:font script="Sora" typeface="Nirmala UI"/>
+        <a:font script="Tale" typeface="Microsoft Tai Le"/>
+        <a:font script="Talu" typeface="Microsoft New Tai Lue"/>
+        <a:font script="Tfng" typeface="Ebrima"/>
+      </a:minorFont>
+    </a:fontScheme>
+    <a:fmtScheme name="Office">
+      <a:fillStyleLst>
+        <a:solidFill>
+          <a:schemeClr val="phClr"/>
+        </a:solidFill>
+        <a:gradFill rotWithShape="1">
+          <a:gsLst>
+            <a:gs pos="0">
+              <a:schemeClr val="phClr">
+                <a:lumMod val="110000"/>
+                <a:satMod val="105000"/>
+                <a:tint val="67000"/>
+              </a:schemeClr>
+            </a:gs>
+            <a:gs pos="50000">
+              <a:schemeClr val="phClr">
+                <a:lumMod val="105000"/>
+                <a:satMod val="103000"/>
+                <a:tint val="73000"/>
+              </a:schemeClr>
+            </a:gs>
+            <a:gs pos="100000">
+              <a:schemeClr val="phClr">
+                <a:lumMod val="105000"/>
+                <a:satMod val="109000"/>
+                <a:tint val="81000"/>
+              </a:schemeClr>
+            </a:gs>
+          </a:gsLst>
+          <a:lin ang="5400000" scaled="0"/>
+        </a:gradFill>
+        <a:gradFill rotWithShape="1">
+          <a:gsLst>
+            <a:gs pos="0">
+              <a:schemeClr val="phClr">
+                <a:satMod val="103000"/>
+                <a:lumMod val="102000"/>
+                <a:tint val="94000"/>
+              </a:schemeClr>
+            </a:gs>
+            <a:gs pos="50000">
+              <a:schemeClr val="phClr">
+                <a:satMod val="110000"/>
+                <a:lumMod val="100000"/>
+                <a:shade val="100000"/>
+              </a:schemeClr>
+            </a:gs>
+            <a:gs pos="100000">
+              <a:schemeClr val="phClr">
+                <a:lumMod val="99000"/>
+                <a:satMod val="120000"/>
+                <a:shade val="78000"/>
+              </a:schemeClr>
+            </a:gs>
+          </a:gsLst>
+          <a:lin ang="5400000" scaled="0"/>
+        </a:gradFill>
+      </a:fillStyleLst>
+      <a:lnStyleLst>
+        <a:ln w="12700" cap="flat" cmpd="sng" algn="ctr">
+          <a:solidFill>
+            <a:schemeClr val="phClr"/>
+          </a:solidFill>
+          <a:prstDash val="solid"/>
+          <a:miter lim="800000"/>
+        </a:ln>
+        <a:ln w="19050" cap="flat" cmpd="sng" algn="ctr">
+          <a:solidFill>
+            <a:schemeClr val="phClr"/>
+          </a:solidFill>
+          <a:prstDash val="solid"/>
+          <a:miter lim="800000"/>
+        </a:ln>
+        <a:ln w="25400" cap="flat" cmpd="sng" algn="ctr">
+          <a:solidFill>
+            <a:schemeClr val="phClr"/>
+          </a:solidFill>
+          <a:prstDash val="solid"/>
+          <a:miter lim="800000"/>
+        </a:ln>
+      </a:lnStyleLst>
+      <a:effectStyleLst>
+        <a:effectStyle>
+          <a:effectLst/>
+        </a:effectStyle>
+        <a:effectStyle>
+          <a:effectLst/>
+        </a:effectStyle>
+        <a:effectStyle>
+          <a:effectLst>
+            <a:outerShdw blurRad="57150" dist="19050" dir="5400000" algn="ctr" rotWithShape="0">
+              <a:srgbClr val="000000">
+                <a:alpha val="63000"/>
+              </a:srgbClr>
+            </a:outerShdw>
+          </a:effectLst>
+        </a:effectStyle>
+      </a:effectStyleLst>
+      <a:bgFillStyleLst>
+        <a:solidFill>
+          <a:schemeClr val="phClr"/>
+        </a:solidFill>
+        <a:solidFill>
+          <a:schemeClr val="phClr">
+            <a:tint val="95000"/>
+            <a:satMod val="170000"/>
+          </a:schemeClr>
+        </a:solidFill>
+        <a:gradFill rotWithShape="1">
+          <a:gsLst>
+            <a:gs pos="0">
+              <a:schemeClr val="phClr">
+                <a:tint val="93000"/>
+                <a:satMod val="150000"/>
+                <a:shade val="98000"/>
+                <a:lumMod val="102000"/>
+              </a:schemeClr>
+            </a:gs>
+            <a:gs pos="50000">
+              <a:schemeClr val="phClr">
+                <a:tint val="98000"/>
+                <a:satMod val="130000"/>
+                <a:shade val="90000"/>
+                <a:lumMod val="103000"/>
+              </a:schemeClr>
+            </a:gs>
+            <a:gs pos="100000">
+              <a:schemeClr val="phClr">
+                <a:shade val="63000"/>
+                <a:satMod val="120000"/>
+              </a:schemeClr>
+            </a:gs>
+          </a:gsLst>
+          <a:lin ang="5400000" scaled="0"/>
+        </a:gradFill>
+      </a:bgFillStyleLst>
+    </a:fmtScheme>
+  </a:themeElements>
+  <a:objectDefaults>
+    <a:lnDef>
+      <a:spPr/>
+      <a:bodyPr/>
+      <a:lstStyle/>
+      <a:style>
+        <a:lnRef idx="2">
+          <a:schemeClr val="accent1"/>
+        </a:lnRef>
+        <a:fillRef idx="0">
+          <a:schemeClr val="accent1"/>
+        </a:fillRef>
+        <a:effectRef idx="1">
+          <a:schemeClr val="accent1"/>
+        </a:effectRef>
+        <a:fontRef idx="minor">
+          <a:schemeClr val="tx1"/>
+        </a:fontRef>
+      </a:style>
+    </a:lnDef>
+  </a:objectDefaults>
+  <a:extraClrSchemeLst/>
+  <a:extLst>
+    <a:ext uri="{05A4C25C-085E-4340-85A3-A5531E510DB2}">
+      <thm15:themeFamily xmlns:thm15="http://schemas.microsoft.com/office/thememl/2012/main" name="Office Theme" id="{2E142A2C-CD16-42D6-873A-C26D2A0506FA}" vid="{1BDDFF52-6CD6-40A5-AB3C-68EB2F1E4D0A}"/>
+    </a:ext>
+  </a:extLst>
+</a:theme>
 </file>
</xml_diff>

<commit_message>
new and improved CAD using smaller sensors
</commit_message>
<xml_diff>
--- a/deliverables/michaelmas_presentation.pptx
+++ b/deliverables/michaelmas_presentation.pptx
@@ -205,7 +205,7 @@
           <a:p>
             <a:fld id="{C0BB89D3-1E85-48CA-BFDB-0FE03B3C9B40}" type="datetimeFigureOut">
               <a:rPr lang="en-GB" smtClean="0"/>
-              <a:t>24/11/2024</a:t>
+              <a:t>25/11/2024</a:t>
             </a:fld>
             <a:endParaRPr lang="en-GB"/>
           </a:p>
@@ -517,6 +517,174 @@
           <a:bodyPr/>
           <a:lstStyle/>
           <a:p>
+            <a:endParaRPr lang="en-GB" dirty="0"/>
+          </a:p>
+        </p:txBody>
+      </p:sp>
+      <p:sp>
+        <p:nvSpPr>
+          <p:cNvPr id="4" name="Slide Number Placeholder 3"/>
+          <p:cNvSpPr>
+            <a:spLocks noGrp="1"/>
+          </p:cNvSpPr>
+          <p:nvPr>
+            <p:ph type="sldNum" sz="quarter" idx="5"/>
+          </p:nvPr>
+        </p:nvSpPr>
+        <p:spPr/>
+        <p:txBody>
+          <a:bodyPr/>
+          <a:lstStyle/>
+          <a:p>
+            <a:fld id="{339AB5C0-8D71-4250-8AD2-76EE22722959}" type="slidenum">
+              <a:rPr lang="en-GB" smtClean="0"/>
+              <a:t>1</a:t>
+            </a:fld>
+            <a:endParaRPr lang="en-GB"/>
+          </a:p>
+        </p:txBody>
+      </p:sp>
+    </p:spTree>
+    <p:extLst>
+      <p:ext uri="{BB962C8B-B14F-4D97-AF65-F5344CB8AC3E}">
+        <p14:creationId xmlns:p14="http://schemas.microsoft.com/office/powerpoint/2010/main" val="2935703679"/>
+      </p:ext>
+    </p:extLst>
+  </p:cSld>
+  <p:clrMapOvr>
+    <a:masterClrMapping/>
+  </p:clrMapOvr>
+</p:notes>
+</file>
+
+<file path=ppt/notesSlides/notesSlide2.xml><?xml version="1.0" encoding="utf-8"?>
+<p:notes xmlns:a="http://schemas.openxmlformats.org/drawingml/2006/main" xmlns:r="http://schemas.openxmlformats.org/officeDocument/2006/relationships" xmlns:p="http://schemas.openxmlformats.org/presentationml/2006/main">
+  <p:cSld>
+    <p:spTree>
+      <p:nvGrpSpPr>
+        <p:cNvPr id="1" name=""/>
+        <p:cNvGrpSpPr/>
+        <p:nvPr/>
+      </p:nvGrpSpPr>
+      <p:grpSpPr>
+        <a:xfrm>
+          <a:off x="0" y="0"/>
+          <a:ext cx="0" cy="0"/>
+          <a:chOff x="0" y="0"/>
+          <a:chExt cx="0" cy="0"/>
+        </a:xfrm>
+      </p:grpSpPr>
+      <p:sp>
+        <p:nvSpPr>
+          <p:cNvPr id="2" name="Slide Image Placeholder 1"/>
+          <p:cNvSpPr>
+            <a:spLocks noGrp="1" noRot="1" noChangeAspect="1"/>
+          </p:cNvSpPr>
+          <p:nvPr>
+            <p:ph type="sldImg"/>
+          </p:nvPr>
+        </p:nvSpPr>
+        <p:spPr/>
+      </p:sp>
+      <p:sp>
+        <p:nvSpPr>
+          <p:cNvPr id="3" name="Notes Placeholder 2"/>
+          <p:cNvSpPr>
+            <a:spLocks noGrp="1"/>
+          </p:cNvSpPr>
+          <p:nvPr>
+            <p:ph type="body" idx="1"/>
+          </p:nvPr>
+        </p:nvSpPr>
+        <p:spPr/>
+        <p:txBody>
+          <a:bodyPr/>
+          <a:lstStyle/>
+          <a:p>
+            <a:endParaRPr lang="en-GB" dirty="0"/>
+          </a:p>
+        </p:txBody>
+      </p:sp>
+      <p:sp>
+        <p:nvSpPr>
+          <p:cNvPr id="4" name="Slide Number Placeholder 3"/>
+          <p:cNvSpPr>
+            <a:spLocks noGrp="1"/>
+          </p:cNvSpPr>
+          <p:nvPr>
+            <p:ph type="sldNum" sz="quarter" idx="5"/>
+          </p:nvPr>
+        </p:nvSpPr>
+        <p:spPr/>
+        <p:txBody>
+          <a:bodyPr/>
+          <a:lstStyle/>
+          <a:p>
+            <a:fld id="{339AB5C0-8D71-4250-8AD2-76EE22722959}" type="slidenum">
+              <a:rPr lang="en-GB" smtClean="0"/>
+              <a:t>2</a:t>
+            </a:fld>
+            <a:endParaRPr lang="en-GB"/>
+          </a:p>
+        </p:txBody>
+      </p:sp>
+    </p:spTree>
+    <p:extLst>
+      <p:ext uri="{BB962C8B-B14F-4D97-AF65-F5344CB8AC3E}">
+        <p14:creationId xmlns:p14="http://schemas.microsoft.com/office/powerpoint/2010/main" val="3772234275"/>
+      </p:ext>
+    </p:extLst>
+  </p:cSld>
+  <p:clrMapOvr>
+    <a:masterClrMapping/>
+  </p:clrMapOvr>
+</p:notes>
+</file>
+
+<file path=ppt/notesSlides/notesSlide3.xml><?xml version="1.0" encoding="utf-8"?>
+<p:notes xmlns:a="http://schemas.openxmlformats.org/drawingml/2006/main" xmlns:r="http://schemas.openxmlformats.org/officeDocument/2006/relationships" xmlns:p="http://schemas.openxmlformats.org/presentationml/2006/main">
+  <p:cSld>
+    <p:spTree>
+      <p:nvGrpSpPr>
+        <p:cNvPr id="1" name=""/>
+        <p:cNvGrpSpPr/>
+        <p:nvPr/>
+      </p:nvGrpSpPr>
+      <p:grpSpPr>
+        <a:xfrm>
+          <a:off x="0" y="0"/>
+          <a:ext cx="0" cy="0"/>
+          <a:chOff x="0" y="0"/>
+          <a:chExt cx="0" cy="0"/>
+        </a:xfrm>
+      </p:grpSpPr>
+      <p:sp>
+        <p:nvSpPr>
+          <p:cNvPr id="2" name="Slide Image Placeholder 1"/>
+          <p:cNvSpPr>
+            <a:spLocks noGrp="1" noRot="1" noChangeAspect="1"/>
+          </p:cNvSpPr>
+          <p:nvPr>
+            <p:ph type="sldImg"/>
+          </p:nvPr>
+        </p:nvSpPr>
+        <p:spPr/>
+      </p:sp>
+      <p:sp>
+        <p:nvSpPr>
+          <p:cNvPr id="3" name="Notes Placeholder 2"/>
+          <p:cNvSpPr>
+            <a:spLocks noGrp="1"/>
+          </p:cNvSpPr>
+          <p:nvPr>
+            <p:ph type="body" idx="1"/>
+          </p:nvPr>
+        </p:nvSpPr>
+        <p:spPr/>
+        <p:txBody>
+          <a:bodyPr/>
+          <a:lstStyle/>
+          <a:p>
             <a:r>
               <a:rPr lang="en-GB" dirty="0"/>
               <a:t>For the experimental setup it's important to consider the parameters needed to define a given propellers performance. Dimensionless thrust and power coefficients can be found from blade tip speed and area. The ratio of these coefficients define a ‘static’ efficiency which is different to the typical propulsive efficiency. The values then required to be measured are the torque, thrust and angular speed.</a:t>
@@ -566,7 +734,7 @@
 </p:notes>
 </file>
 
-<file path=ppt/notesSlides/notesSlide2.xml><?xml version="1.0" encoding="utf-8"?>
+<file path=ppt/notesSlides/notesSlide4.xml><?xml version="1.0" encoding="utf-8"?>
 <p:notes xmlns:a="http://schemas.openxmlformats.org/drawingml/2006/main" xmlns:r="http://schemas.openxmlformats.org/officeDocument/2006/relationships" xmlns:p="http://schemas.openxmlformats.org/presentationml/2006/main">
   <p:cSld>
     <p:spTree>
@@ -802,7 +970,7 @@
           <a:p>
             <a:fld id="{B8C3C57F-C92A-483E-A8E5-2F94B59C9323}" type="datetimeFigureOut">
               <a:rPr lang="en-GB" smtClean="0"/>
-              <a:t>24/11/2024</a:t>
+              <a:t>25/11/2024</a:t>
             </a:fld>
             <a:endParaRPr lang="en-GB"/>
           </a:p>
@@ -1002,7 +1170,7 @@
           <a:p>
             <a:fld id="{B8C3C57F-C92A-483E-A8E5-2F94B59C9323}" type="datetimeFigureOut">
               <a:rPr lang="en-GB" smtClean="0"/>
-              <a:t>24/11/2024</a:t>
+              <a:t>25/11/2024</a:t>
             </a:fld>
             <a:endParaRPr lang="en-GB"/>
           </a:p>
@@ -1212,7 +1380,7 @@
           <a:p>
             <a:fld id="{B8C3C57F-C92A-483E-A8E5-2F94B59C9323}" type="datetimeFigureOut">
               <a:rPr lang="en-GB" smtClean="0"/>
-              <a:t>24/11/2024</a:t>
+              <a:t>25/11/2024</a:t>
             </a:fld>
             <a:endParaRPr lang="en-GB"/>
           </a:p>
@@ -1412,7 +1580,7 @@
           <a:p>
             <a:fld id="{B8C3C57F-C92A-483E-A8E5-2F94B59C9323}" type="datetimeFigureOut">
               <a:rPr lang="en-GB" smtClean="0"/>
-              <a:t>24/11/2024</a:t>
+              <a:t>25/11/2024</a:t>
             </a:fld>
             <a:endParaRPr lang="en-GB"/>
           </a:p>
@@ -1688,7 +1856,7 @@
           <a:p>
             <a:fld id="{B8C3C57F-C92A-483E-A8E5-2F94B59C9323}" type="datetimeFigureOut">
               <a:rPr lang="en-GB" smtClean="0"/>
-              <a:t>24/11/2024</a:t>
+              <a:t>25/11/2024</a:t>
             </a:fld>
             <a:endParaRPr lang="en-GB"/>
           </a:p>
@@ -1956,7 +2124,7 @@
           <a:p>
             <a:fld id="{B8C3C57F-C92A-483E-A8E5-2F94B59C9323}" type="datetimeFigureOut">
               <a:rPr lang="en-GB" smtClean="0"/>
-              <a:t>24/11/2024</a:t>
+              <a:t>25/11/2024</a:t>
             </a:fld>
             <a:endParaRPr lang="en-GB"/>
           </a:p>
@@ -2371,7 +2539,7 @@
           <a:p>
             <a:fld id="{B8C3C57F-C92A-483E-A8E5-2F94B59C9323}" type="datetimeFigureOut">
               <a:rPr lang="en-GB" smtClean="0"/>
-              <a:t>24/11/2024</a:t>
+              <a:t>25/11/2024</a:t>
             </a:fld>
             <a:endParaRPr lang="en-GB"/>
           </a:p>
@@ -2513,7 +2681,7 @@
           <a:p>
             <a:fld id="{B8C3C57F-C92A-483E-A8E5-2F94B59C9323}" type="datetimeFigureOut">
               <a:rPr lang="en-GB" smtClean="0"/>
-              <a:t>24/11/2024</a:t>
+              <a:t>25/11/2024</a:t>
             </a:fld>
             <a:endParaRPr lang="en-GB"/>
           </a:p>
@@ -2626,7 +2794,7 @@
           <a:p>
             <a:fld id="{B8C3C57F-C92A-483E-A8E5-2F94B59C9323}" type="datetimeFigureOut">
               <a:rPr lang="en-GB" smtClean="0"/>
-              <a:t>24/11/2024</a:t>
+              <a:t>25/11/2024</a:t>
             </a:fld>
             <a:endParaRPr lang="en-GB"/>
           </a:p>
@@ -2939,7 +3107,7 @@
           <a:p>
             <a:fld id="{B8C3C57F-C92A-483E-A8E5-2F94B59C9323}" type="datetimeFigureOut">
               <a:rPr lang="en-GB" smtClean="0"/>
-              <a:t>24/11/2024</a:t>
+              <a:t>25/11/2024</a:t>
             </a:fld>
             <a:endParaRPr lang="en-GB"/>
           </a:p>
@@ -3228,7 +3396,7 @@
           <a:p>
             <a:fld id="{B8C3C57F-C92A-483E-A8E5-2F94B59C9323}" type="datetimeFigureOut">
               <a:rPr lang="en-GB" smtClean="0"/>
-              <a:t>24/11/2024</a:t>
+              <a:t>25/11/2024</a:t>
             </a:fld>
             <a:endParaRPr lang="en-GB"/>
           </a:p>
@@ -3471,7 +3639,7 @@
           <a:p>
             <a:fld id="{B8C3C57F-C92A-483E-A8E5-2F94B59C9323}" type="datetimeFigureOut">
               <a:rPr lang="en-GB" smtClean="0"/>
-              <a:t>24/11/2024</a:t>
+              <a:t>25/11/2024</a:t>
             </a:fld>
             <a:endParaRPr lang="en-GB"/>
           </a:p>
@@ -3937,7 +4105,16 @@
           <a:bodyPr/>
           <a:lstStyle/>
           <a:p>
-            <a:endParaRPr lang="en-GB" dirty="0"/>
+            <a:r>
+              <a:rPr lang="en-GB" dirty="0"/>
+              <a:t>Louis Pender</a:t>
+            </a:r>
+          </a:p>
+          <a:p>
+            <a:r>
+              <a:rPr lang="en-GB" dirty="0"/>
+              <a:t>Lwp26</a:t>
+            </a:r>
           </a:p>
         </p:txBody>
       </p:sp>
@@ -4015,7 +4192,12 @@
             <p:ph idx="1"/>
           </p:nvPr>
         </p:nvSpPr>
-        <p:spPr/>
+        <p:spPr>
+          <a:xfrm>
+            <a:off x="838200" y="1516136"/>
+            <a:ext cx="10515600" cy="4351338"/>
+          </a:xfrm>
+        </p:spPr>
         <p:txBody>
           <a:bodyPr/>
           <a:lstStyle/>
@@ -4144,7 +4326,7 @@
         </p:nvSpPr>
         <p:spPr>
           <a:xfrm>
-            <a:off x="838200" y="1325562"/>
+            <a:off x="838200" y="1418394"/>
             <a:ext cx="10515600" cy="5208491"/>
           </a:xfrm>
         </p:spPr>
@@ -4439,6 +4621,81 @@
   <p:clrMapOvr>
     <a:masterClrMapping/>
   </p:clrMapOvr>
+  <p:timing>
+    <p:tnLst>
+      <p:par>
+        <p:cTn id="1" dur="indefinite" restart="never" nodeType="tmRoot">
+          <p:childTnLst>
+            <p:seq concurrent="1" nextAc="seek">
+              <p:cTn id="2" dur="indefinite" nodeType="mainSeq">
+                <p:childTnLst>
+                  <p:par>
+                    <p:cTn id="3" fill="hold">
+                      <p:stCondLst>
+                        <p:cond delay="indefinite"/>
+                      </p:stCondLst>
+                      <p:childTnLst>
+                        <p:par>
+                          <p:cTn id="4" fill="hold">
+                            <p:stCondLst>
+                              <p:cond delay="0"/>
+                            </p:stCondLst>
+                            <p:childTnLst>
+                              <p:par>
+                                <p:cTn id="5" presetID="1" presetClass="entr" presetSubtype="0" fill="hold" nodeType="clickEffect">
+                                  <p:stCondLst>
+                                    <p:cond delay="0"/>
+                                  </p:stCondLst>
+                                  <p:childTnLst>
+                                    <p:set>
+                                      <p:cBhvr>
+                                        <p:cTn id="6" dur="1" fill="hold">
+                                          <p:stCondLst>
+                                            <p:cond delay="0"/>
+                                          </p:stCondLst>
+                                        </p:cTn>
+                                        <p:tgtEl>
+                                          <p:spTgt spid="4"/>
+                                        </p:tgtEl>
+                                        <p:attrNameLst>
+                                          <p:attrName>style.visibility</p:attrName>
+                                        </p:attrNameLst>
+                                      </p:cBhvr>
+                                      <p:to>
+                                        <p:strVal val="visible"/>
+                                      </p:to>
+                                    </p:set>
+                                  </p:childTnLst>
+                                </p:cTn>
+                              </p:par>
+                            </p:childTnLst>
+                          </p:cTn>
+                        </p:par>
+                      </p:childTnLst>
+                    </p:cTn>
+                  </p:par>
+                </p:childTnLst>
+              </p:cTn>
+              <p:prevCondLst>
+                <p:cond evt="onPrev" delay="0">
+                  <p:tgtEl>
+                    <p:sldTgt/>
+                  </p:tgtEl>
+                </p:cond>
+              </p:prevCondLst>
+              <p:nextCondLst>
+                <p:cond evt="onNext" delay="0">
+                  <p:tgtEl>
+                    <p:sldTgt/>
+                  </p:tgtEl>
+                </p:cond>
+              </p:nextCondLst>
+            </p:seq>
+          </p:childTnLst>
+        </p:cTn>
+      </p:par>
+    </p:tnLst>
+  </p:timing>
 </p:sld>
 </file>
 
@@ -4508,13 +4765,16 @@
           <a:bodyPr/>
           <a:lstStyle/>
           <a:p>
+            <a:pPr marL="0" indent="0">
+              <a:buNone/>
+            </a:pPr>
+            <a:endParaRPr lang="en-GB" dirty="0"/>
+          </a:p>
+          <a:p>
             <a:r>
               <a:rPr lang="en-GB" dirty="0"/>
-              <a:t>Improvements in efficiency</a:t>
-            </a:r>
-          </a:p>
-          <a:p>
-            <a:endParaRPr lang="en-GB" dirty="0"/>
+              <a:t>The </a:t>
+            </a:r>
           </a:p>
         </p:txBody>
       </p:sp>
@@ -4581,8 +4841,8 @@
           </a:p>
         </p:txBody>
       </p:sp>
-      <mc:AlternateContent xmlns:mc="http://schemas.openxmlformats.org/markup-compatibility/2006">
-        <mc:Choice xmlns:a14="http://schemas.microsoft.com/office/drawing/2010/main" Requires="a14">
+      <mc:AlternateContent xmlns:mc="http://schemas.openxmlformats.org/markup-compatibility/2006" xmlns:a14="http://schemas.microsoft.com/office/drawing/2010/main">
+        <mc:Choice Requires="a14">
           <p:sp>
             <p:nvSpPr>
               <p:cNvPr id="3" name="Content Placeholder 2">
@@ -4915,7 +5175,7 @@
             </p:txBody>
           </p:sp>
         </mc:Choice>
-        <mc:Fallback>
+        <mc:Fallback xmlns="">
           <p:sp>
             <p:nvSpPr>
               <p:cNvPr id="3" name="Content Placeholder 2">

</xml_diff>

<commit_message>
improved image for ppt
</commit_message>
<xml_diff>
--- a/deliverables/michaelmas_presentation.pptx
+++ b/deliverables/michaelmas_presentation.pptx
@@ -748,6 +748,21 @@
               <a:t>It's also worth noting that these trailing edge serrations at low Reynolds numbers were inspired by owl wings.</a:t>
             </a:r>
           </a:p>
+          <a:p>
+            <a:endParaRPr lang="en-GB" dirty="0"/>
+          </a:p>
+          <a:p>
+            <a:r>
+              <a:rPr lang="en-GB" dirty="0"/>
+              <a:t>This needs to be naturally and indirectly introduced by exploring the problem of aero acoustic performance</a:t>
+            </a:r>
+          </a:p>
+          <a:p>
+            <a:r>
+              <a:rPr lang="en-GB" dirty="0"/>
+              <a:t>Treat as large design space </a:t>
+            </a:r>
+          </a:p>
         </p:txBody>
       </p:sp>
       <p:sp>
@@ -835,6 +850,15 @@
               <a:t>The key designs considered in this project will be uneven blade span and toroidal on the right.</a:t>
             </a:r>
           </a:p>
+          <a:p>
+            <a:endParaRPr lang="en-GB" dirty="0"/>
+          </a:p>
+          <a:p>
+            <a:r>
+              <a:rPr lang="en-GB" dirty="0"/>
+              <a:t>This needs to be introduced after </a:t>
+            </a:r>
+          </a:p>
         </p:txBody>
       </p:sp>
       <p:sp>
@@ -1012,8 +1036,23 @@
           <a:p>
             <a:r>
               <a:rPr lang="en-GB" dirty="0"/>
-              <a:t>For the experimental setup it's important to consider the parameters needed to define a given propellers performance. Dimensionless thrust and power coefficients can be found from blade tip speed and area. The ratio of these coefficients define a ‘static’ efficiency which is different to the typical propulsive efficiency. The values then required to be measured are the torque, thrust and angular speed.</a:t>
-            </a:r>
+              <a:t>For the experimental setup it's important to consider the parameters needed to define a given propellers performance. Dimensionless thrust and power coefficients can be found from blade tip speed and area. </a:t>
+            </a:r>
+          </a:p>
+          <a:p>
+            <a:endParaRPr lang="en-GB" dirty="0"/>
+          </a:p>
+          <a:p>
+            <a:endParaRPr lang="en-GB" dirty="0"/>
+          </a:p>
+          <a:p>
+            <a:r>
+              <a:rPr lang="en-GB" dirty="0"/>
+              <a:t>Add coefficient of merit</a:t>
+            </a:r>
+          </a:p>
+          <a:p>
+            <a:endParaRPr lang="en-GB" dirty="0"/>
           </a:p>
           <a:p>
             <a:endParaRPr lang="en-GB" dirty="0"/>
@@ -1113,6 +1152,12 @@
           </a:p>
           <a:p>
             <a:endParaRPr lang="en-GB" dirty="0"/>
+          </a:p>
+          <a:p>
+            <a:r>
+              <a:rPr lang="en-GB" dirty="0"/>
+              <a:t>Current work</a:t>
+            </a:r>
           </a:p>
         </p:txBody>
       </p:sp>
@@ -5313,7 +5358,7 @@
           <a:p>
             <a:r>
               <a:rPr lang="en-GB" dirty="0"/>
-              <a:t>Conclusion/Hypothesis</a:t>
+              <a:t>Hypothesis</a:t>
             </a:r>
           </a:p>
         </p:txBody>
@@ -5339,7 +5384,36 @@
           <a:bodyPr/>
           <a:lstStyle/>
           <a:p>
+            <a:r>
+              <a:rPr lang="en-GB" dirty="0"/>
+              <a:t>Variable blade span could promote mixing of wing tip vortices, reducing  tonal sound</a:t>
+            </a:r>
+          </a:p>
+          <a:p>
             <a:endParaRPr lang="en-GB" dirty="0"/>
+          </a:p>
+          <a:p>
+            <a:r>
+              <a:rPr lang="en-GB" dirty="0"/>
+              <a:t>Serrations on trailing edge of front loop or closely spaced propellers will reduce blade wake interaction and hence the broadband noise</a:t>
+            </a:r>
+          </a:p>
+          <a:p>
+            <a:endParaRPr lang="en-GB" dirty="0"/>
+          </a:p>
+          <a:p>
+            <a:r>
+              <a:rPr lang="en-GB" dirty="0"/>
+              <a:t>High loading at the tip will produce stronger </a:t>
+            </a:r>
+            <a:r>
+              <a:rPr lang="en-GB" dirty="0" err="1"/>
+              <a:t>vorticies</a:t>
+            </a:r>
+            <a:r>
+              <a:rPr lang="en-GB" dirty="0"/>
+              <a:t> </a:t>
+            </a:r>
           </a:p>
         </p:txBody>
       </p:sp>
@@ -6515,8 +6589,8 @@
         </p:nvGrpSpPr>
         <p:grpSpPr>
           <a:xfrm>
-            <a:off x="7287219" y="441171"/>
-            <a:ext cx="4445431" cy="1948368"/>
+            <a:off x="6354438" y="1175989"/>
+            <a:ext cx="5457290" cy="2487338"/>
             <a:chOff x="459350" y="4615094"/>
             <a:chExt cx="4445431" cy="1948368"/>
           </a:xfrm>
@@ -6608,38 +6682,8 @@
         </p:blipFill>
         <p:spPr>
           <a:xfrm>
-            <a:off x="6724323" y="2667429"/>
+            <a:off x="6748308" y="2674954"/>
             <a:ext cx="5026054" cy="4033394"/>
-          </a:xfrm>
-          <a:prstGeom prst="rect">
-            <a:avLst/>
-          </a:prstGeom>
-        </p:spPr>
-      </p:pic>
-      <p:pic>
-        <p:nvPicPr>
-          <p:cNvPr id="30" name="Picture 29">
-            <a:extLst>
-              <a:ext uri="{FF2B5EF4-FFF2-40B4-BE49-F238E27FC236}">
-                <a16:creationId xmlns:a16="http://schemas.microsoft.com/office/drawing/2014/main" id="{7CD423FC-03F4-D5A1-2483-AE0A82548D4C}"/>
-              </a:ext>
-            </a:extLst>
-          </p:cNvPr>
-          <p:cNvPicPr>
-            <a:picLocks noChangeAspect="1"/>
-          </p:cNvPicPr>
-          <p:nvPr/>
-        </p:nvPicPr>
-        <p:blipFill>
-          <a:blip r:embed="rId5"/>
-          <a:stretch>
-            <a:fillRect/>
-          </a:stretch>
-        </p:blipFill>
-        <p:spPr>
-          <a:xfrm>
-            <a:off x="420859" y="4590779"/>
-            <a:ext cx="5861841" cy="1827277"/>
           </a:xfrm>
           <a:prstGeom prst="rect">
             <a:avLst/>
@@ -6681,47 +6725,12 @@
           </a:p>
         </p:txBody>
       </p:sp>
-      <p:sp>
-        <p:nvSpPr>
-          <p:cNvPr id="34" name="TextBox 33">
-            <a:extLst>
-              <a:ext uri="{FF2B5EF4-FFF2-40B4-BE49-F238E27FC236}">
-                <a16:creationId xmlns:a16="http://schemas.microsoft.com/office/drawing/2014/main" id="{C21B5BFC-0666-1747-43A2-6F76CB712D48}"/>
-              </a:ext>
-            </a:extLst>
-          </p:cNvPr>
-          <p:cNvSpPr txBox="1"/>
-          <p:nvPr/>
-        </p:nvSpPr>
-        <p:spPr>
-          <a:xfrm>
-            <a:off x="2403245" y="5703934"/>
-            <a:ext cx="1654405" cy="369332"/>
-          </a:xfrm>
-          <a:prstGeom prst="rect">
-            <a:avLst/>
-          </a:prstGeom>
-          <a:noFill/>
-        </p:spPr>
-        <p:txBody>
-          <a:bodyPr wrap="square">
-            <a:spAutoFit/>
-          </a:bodyPr>
-          <a:lstStyle/>
-          <a:p>
-            <a:r>
-              <a:rPr lang="en-GB" dirty="0"/>
-              <a:t>B. Zang et al.</a:t>
-            </a:r>
-          </a:p>
-        </p:txBody>
-      </p:sp>
       <p:grpSp>
         <p:nvGrpSpPr>
-          <p:cNvPr id="13" name="Group 12">
-            <a:extLst>
-              <a:ext uri="{FF2B5EF4-FFF2-40B4-BE49-F238E27FC236}">
-                <a16:creationId xmlns:a16="http://schemas.microsoft.com/office/drawing/2014/main" id="{30C9D165-BE70-4E74-4603-F7C49AD44FC9}"/>
+          <p:cNvPr id="5" name="Group 4">
+            <a:extLst>
+              <a:ext uri="{FF2B5EF4-FFF2-40B4-BE49-F238E27FC236}">
+                <a16:creationId xmlns:a16="http://schemas.microsoft.com/office/drawing/2014/main" id="{5DDEF540-2758-FFDA-4A9A-934D0BF28A52}"/>
               </a:ext>
             </a:extLst>
           </p:cNvPr>
@@ -6730,48 +6739,155 @@
         </p:nvGrpSpPr>
         <p:grpSpPr>
           <a:xfrm>
-            <a:off x="6282700" y="3570606"/>
-            <a:ext cx="5336037" cy="3001521"/>
-            <a:chOff x="6282700" y="3570606"/>
-            <a:chExt cx="5336037" cy="3001521"/>
+            <a:off x="392205" y="3487974"/>
+            <a:ext cx="11197878" cy="3001521"/>
+            <a:chOff x="392205" y="3487974"/>
+            <a:chExt cx="11197878" cy="3001521"/>
           </a:xfrm>
         </p:grpSpPr>
-        <p:pic>
-          <p:nvPicPr>
-            <p:cNvPr id="6" name="Picture 5">
+        <p:grpSp>
+          <p:nvGrpSpPr>
+            <p:cNvPr id="4" name="Group 3">
               <a:extLst>
                 <a:ext uri="{FF2B5EF4-FFF2-40B4-BE49-F238E27FC236}">
-                  <a16:creationId xmlns:a16="http://schemas.microsoft.com/office/drawing/2014/main" id="{8E28C63F-94ED-AE22-8F66-C521AF20E882}"/>
+                  <a16:creationId xmlns:a16="http://schemas.microsoft.com/office/drawing/2014/main" id="{5EA873DD-E14A-D8F1-79ED-D3A98497AA28}"/>
                 </a:ext>
               </a:extLst>
             </p:cNvPr>
-            <p:cNvPicPr>
-              <a:picLocks noChangeAspect="1"/>
-            </p:cNvPicPr>
+            <p:cNvGrpSpPr/>
             <p:nvPr/>
-          </p:nvPicPr>
-          <p:blipFill>
-            <a:blip r:embed="rId6"/>
-            <a:stretch>
-              <a:fillRect/>
-            </a:stretch>
-          </p:blipFill>
-          <p:spPr>
+          </p:nvGrpSpPr>
+          <p:grpSpPr>
             <a:xfrm>
-              <a:off x="6282700" y="3570606"/>
-              <a:ext cx="5336037" cy="3001521"/>
+              <a:off x="392205" y="3487974"/>
+              <a:ext cx="11197878" cy="3001521"/>
+              <a:chOff x="420859" y="3570606"/>
+              <a:chExt cx="11197878" cy="3001521"/>
             </a:xfrm>
-            <a:prstGeom prst="rect">
-              <a:avLst/>
-            </a:prstGeom>
-          </p:spPr>
-        </p:pic>
+          </p:grpSpPr>
+          <p:pic>
+            <p:nvPicPr>
+              <p:cNvPr id="30" name="Picture 29">
+                <a:extLst>
+                  <a:ext uri="{FF2B5EF4-FFF2-40B4-BE49-F238E27FC236}">
+                    <a16:creationId xmlns:a16="http://schemas.microsoft.com/office/drawing/2014/main" id="{7CD423FC-03F4-D5A1-2483-AE0A82548D4C}"/>
+                  </a:ext>
+                </a:extLst>
+              </p:cNvPr>
+              <p:cNvPicPr>
+                <a:picLocks noChangeAspect="1"/>
+              </p:cNvPicPr>
+              <p:nvPr/>
+            </p:nvPicPr>
+            <p:blipFill>
+              <a:blip r:embed="rId5"/>
+              <a:stretch>
+                <a:fillRect/>
+              </a:stretch>
+            </p:blipFill>
+            <p:spPr>
+              <a:xfrm>
+                <a:off x="420859" y="4590779"/>
+                <a:ext cx="5861841" cy="1827277"/>
+              </a:xfrm>
+              <a:prstGeom prst="rect">
+                <a:avLst/>
+              </a:prstGeom>
+            </p:spPr>
+          </p:pic>
+          <p:grpSp>
+            <p:nvGrpSpPr>
+              <p:cNvPr id="13" name="Group 12">
+                <a:extLst>
+                  <a:ext uri="{FF2B5EF4-FFF2-40B4-BE49-F238E27FC236}">
+                    <a16:creationId xmlns:a16="http://schemas.microsoft.com/office/drawing/2014/main" id="{30C9D165-BE70-4E74-4603-F7C49AD44FC9}"/>
+                  </a:ext>
+                </a:extLst>
+              </p:cNvPr>
+              <p:cNvGrpSpPr/>
+              <p:nvPr/>
+            </p:nvGrpSpPr>
+            <p:grpSpPr>
+              <a:xfrm>
+                <a:off x="6282700" y="3570606"/>
+                <a:ext cx="5336037" cy="3001521"/>
+                <a:chOff x="6282700" y="3570606"/>
+                <a:chExt cx="5336037" cy="3001521"/>
+              </a:xfrm>
+            </p:grpSpPr>
+            <p:pic>
+              <p:nvPicPr>
+                <p:cNvPr id="6" name="Picture 5">
+                  <a:extLst>
+                    <a:ext uri="{FF2B5EF4-FFF2-40B4-BE49-F238E27FC236}">
+                      <a16:creationId xmlns:a16="http://schemas.microsoft.com/office/drawing/2014/main" id="{8E28C63F-94ED-AE22-8F66-C521AF20E882}"/>
+                    </a:ext>
+                  </a:extLst>
+                </p:cNvPr>
+                <p:cNvPicPr>
+                  <a:picLocks noChangeAspect="1"/>
+                </p:cNvPicPr>
+                <p:nvPr/>
+              </p:nvPicPr>
+              <p:blipFill>
+                <a:blip r:embed="rId6"/>
+                <a:stretch>
+                  <a:fillRect/>
+                </a:stretch>
+              </p:blipFill>
+              <p:spPr>
+                <a:xfrm>
+                  <a:off x="6282700" y="3570606"/>
+                  <a:ext cx="5336037" cy="3001521"/>
+                </a:xfrm>
+                <a:prstGeom prst="rect">
+                  <a:avLst/>
+                </a:prstGeom>
+              </p:spPr>
+            </p:pic>
+            <p:sp>
+              <p:nvSpPr>
+                <p:cNvPr id="11" name="TextBox 10">
+                  <a:extLst>
+                    <a:ext uri="{FF2B5EF4-FFF2-40B4-BE49-F238E27FC236}">
+                      <a16:creationId xmlns:a16="http://schemas.microsoft.com/office/drawing/2014/main" id="{D6258E11-FAAE-C175-D482-1D2F77033364}"/>
+                    </a:ext>
+                  </a:extLst>
+                </p:cNvPr>
+                <p:cNvSpPr txBox="1"/>
+                <p:nvPr/>
+              </p:nvSpPr>
+              <p:spPr>
+                <a:xfrm>
+                  <a:off x="8043808" y="3816655"/>
+                  <a:ext cx="2135859" cy="369332"/>
+                </a:xfrm>
+                <a:prstGeom prst="rect">
+                  <a:avLst/>
+                </a:prstGeom>
+                <a:noFill/>
+              </p:spPr>
+              <p:txBody>
+                <a:bodyPr wrap="square">
+                  <a:spAutoFit/>
+                </a:bodyPr>
+                <a:lstStyle/>
+                <a:p>
+                  <a:r>
+                    <a:rPr lang="en-GB" dirty="0"/>
+                    <a:t>L. Wang et al.</a:t>
+                  </a:r>
+                </a:p>
+              </p:txBody>
+            </p:sp>
+          </p:grpSp>
+        </p:grpSp>
         <p:sp>
           <p:nvSpPr>
-            <p:cNvPr id="11" name="TextBox 10">
+            <p:cNvPr id="34" name="TextBox 33">
               <a:extLst>
                 <a:ext uri="{FF2B5EF4-FFF2-40B4-BE49-F238E27FC236}">
-                  <a16:creationId xmlns:a16="http://schemas.microsoft.com/office/drawing/2014/main" id="{D6258E11-FAAE-C175-D482-1D2F77033364}"/>
+                  <a16:creationId xmlns:a16="http://schemas.microsoft.com/office/drawing/2014/main" id="{C21B5BFC-0666-1747-43A2-6F76CB712D48}"/>
                 </a:ext>
               </a:extLst>
             </p:cNvPr>
@@ -6780,8 +6896,8 @@
           </p:nvSpPr>
           <p:spPr>
             <a:xfrm>
-              <a:off x="8043808" y="3816655"/>
-              <a:ext cx="2135859" cy="369332"/>
+              <a:off x="2403245" y="5703934"/>
+              <a:ext cx="1654405" cy="369332"/>
             </a:xfrm>
             <a:prstGeom prst="rect">
               <a:avLst/>
@@ -6796,7 +6912,7 @@
             <a:p>
               <a:r>
                 <a:rPr lang="en-GB" dirty="0"/>
-                <a:t>L. Wang et al.</a:t>
+                <a:t>B. Zang et al.</a:t>
               </a:r>
             </a:p>
           </p:txBody>
@@ -6846,7 +6962,52 @@
                                           </p:stCondLst>
                                         </p:cTn>
                                         <p:tgtEl>
-                                          <p:spTgt spid="13"/>
+                                          <p:spTgt spid="26"/>
+                                        </p:tgtEl>
+                                        <p:attrNameLst>
+                                          <p:attrName>style.visibility</p:attrName>
+                                        </p:attrNameLst>
+                                      </p:cBhvr>
+                                      <p:to>
+                                        <p:strVal val="visible"/>
+                                      </p:to>
+                                    </p:set>
+                                  </p:childTnLst>
+                                </p:cTn>
+                              </p:par>
+                            </p:childTnLst>
+                          </p:cTn>
+                        </p:par>
+                      </p:childTnLst>
+                    </p:cTn>
+                  </p:par>
+                  <p:par>
+                    <p:cTn id="7" fill="hold">
+                      <p:stCondLst>
+                        <p:cond delay="indefinite"/>
+                      </p:stCondLst>
+                      <p:childTnLst>
+                        <p:par>
+                          <p:cTn id="8" fill="hold">
+                            <p:stCondLst>
+                              <p:cond delay="0"/>
+                            </p:stCondLst>
+                            <p:childTnLst>
+                              <p:par>
+                                <p:cTn id="9" presetID="1" presetClass="entr" presetSubtype="0" fill="hold" nodeType="clickEffect">
+                                  <p:stCondLst>
+                                    <p:cond delay="0"/>
+                                  </p:stCondLst>
+                                  <p:childTnLst>
+                                    <p:set>
+                                      <p:cBhvr>
+                                        <p:cTn id="10" dur="1" fill="hold">
+                                          <p:stCondLst>
+                                            <p:cond delay="0"/>
+                                          </p:stCondLst>
+                                        </p:cTn>
+                                        <p:tgtEl>
+                                          <p:spTgt spid="5"/>
                                         </p:tgtEl>
                                         <p:attrNameLst>
                                           <p:attrName>style.visibility</p:attrName>
@@ -7005,55 +7166,6 @@
           </a:p>
         </p:txBody>
       </p:sp>
-      <p:sp>
-        <p:nvSpPr>
-          <p:cNvPr id="10" name="Rectangle 9">
-            <a:extLst>
-              <a:ext uri="{FF2B5EF4-FFF2-40B4-BE49-F238E27FC236}">
-                <a16:creationId xmlns:a16="http://schemas.microsoft.com/office/drawing/2014/main" id="{DF87DB04-9879-0400-BB66-6CD4B59A734D}"/>
-              </a:ext>
-            </a:extLst>
-          </p:cNvPr>
-          <p:cNvSpPr/>
-          <p:nvPr/>
-        </p:nvSpPr>
-        <p:spPr>
-          <a:xfrm>
-            <a:off x="1215736" y="1787236"/>
-            <a:ext cx="4363013" cy="4094019"/>
-          </a:xfrm>
-          <a:prstGeom prst="rect">
-            <a:avLst/>
-          </a:prstGeom>
-        </p:spPr>
-        <p:style>
-          <a:lnRef idx="2">
-            <a:schemeClr val="accent1">
-              <a:shade val="15000"/>
-            </a:schemeClr>
-          </a:lnRef>
-          <a:fillRef idx="1">
-            <a:schemeClr val="accent1"/>
-          </a:fillRef>
-          <a:effectRef idx="0">
-            <a:schemeClr val="accent1"/>
-          </a:effectRef>
-          <a:fontRef idx="minor">
-            <a:schemeClr val="lt1"/>
-          </a:fontRef>
-        </p:style>
-        <p:txBody>
-          <a:bodyPr rtlCol="0" anchor="ctr"/>
-          <a:lstStyle/>
-          <a:p>
-            <a:pPr algn="ctr"/>
-            <a:r>
-              <a:rPr lang="en-GB" dirty="0"/>
-              <a:t>Uneven blade span</a:t>
-            </a:r>
-          </a:p>
-        </p:txBody>
-      </p:sp>
     </p:spTree>
     <p:extLst>
       <p:ext uri="{BB962C8B-B14F-4D97-AF65-F5344CB8AC3E}">
@@ -8040,8 +8152,8 @@
           </a:p>
         </p:txBody>
       </p:sp>
-      <mc:AlternateContent xmlns:mc="http://schemas.openxmlformats.org/markup-compatibility/2006">
-        <mc:Choice xmlns:a14="http://schemas.microsoft.com/office/drawing/2010/main" Requires="a14">
+      <mc:AlternateContent xmlns:mc="http://schemas.openxmlformats.org/markup-compatibility/2006" xmlns:a14="http://schemas.microsoft.com/office/drawing/2010/main">
+        <mc:Choice Requires="a14">
           <p:sp>
             <p:nvSpPr>
               <p:cNvPr id="3" name="Content Placeholder 2">
@@ -8376,7 +8488,7 @@
             </p:txBody>
           </p:sp>
         </mc:Choice>
-        <mc:Fallback>
+        <mc:Fallback xmlns="">
           <p:sp>
             <p:nvSpPr>
               <p:cNvPr id="3" name="Content Placeholder 2">
@@ -8657,8 +8769,8 @@
         </p:nvSpPr>
         <p:spPr>
           <a:xfrm>
-            <a:off x="838200" y="1825624"/>
-            <a:ext cx="10515600" cy="4367785"/>
+            <a:off x="709774" y="1830762"/>
+            <a:ext cx="6333162" cy="4367785"/>
           </a:xfrm>
         </p:spPr>
         <p:txBody>
@@ -8672,45 +8784,246 @@
             </a:pPr>
             <a:r>
               <a:rPr lang="en-GB" dirty="0"/>
-              <a:t>Can be separated into tonal and broadband.</a:t>
-            </a:r>
-          </a:p>
+              <a:t>Noise separated into</a:t>
+            </a:r>
+          </a:p>
+          <a:p>
+            <a:r>
+              <a:rPr lang="en-GB" dirty="0"/>
+              <a:t>Discrete frequency tonal noise</a:t>
+            </a:r>
+          </a:p>
+          <a:p>
+            <a:r>
+              <a:rPr lang="en-GB" dirty="0"/>
+              <a:t>Broadband</a:t>
+            </a:r>
+          </a:p>
+        </p:txBody>
+      </p:sp>
+      <p:sp>
+        <p:nvSpPr>
+          <p:cNvPr id="6" name="Content Placeholder 2">
+            <a:extLst>
+              <a:ext uri="{FF2B5EF4-FFF2-40B4-BE49-F238E27FC236}">
+                <a16:creationId xmlns:a16="http://schemas.microsoft.com/office/drawing/2014/main" id="{7BACF53C-DB37-050E-6D7F-B0341BBAECF9}"/>
+              </a:ext>
+            </a:extLst>
+          </p:cNvPr>
+          <p:cNvSpPr txBox="1">
+            <a:spLocks/>
+          </p:cNvSpPr>
+          <p:nvPr/>
+        </p:nvSpPr>
+        <p:spPr>
+          <a:xfrm>
+            <a:off x="6446178" y="1736582"/>
+            <a:ext cx="5857126" cy="4367785"/>
+          </a:xfrm>
+          <a:prstGeom prst="rect">
+            <a:avLst/>
+          </a:prstGeom>
+        </p:spPr>
+        <p:txBody>
+          <a:bodyPr vert="horz" lIns="91440" tIns="45720" rIns="91440" bIns="45720" rtlCol="0">
+            <a:normAutofit/>
+          </a:bodyPr>
+          <a:lstStyle>
+            <a:lvl1pPr marL="228600" indent="-228600" algn="l" defTabSz="914400" rtl="0" eaLnBrk="1" latinLnBrk="0" hangingPunct="1">
+              <a:lnSpc>
+                <a:spcPct val="90000"/>
+              </a:lnSpc>
+              <a:spcBef>
+                <a:spcPts val="1000"/>
+              </a:spcBef>
+              <a:buFont typeface="Arial" panose="020B0604020202020204" pitchFamily="34" charset="0"/>
+              <a:buChar char="•"/>
+              <a:defRPr sz="2800" kern="1200">
+                <a:solidFill>
+                  <a:schemeClr val="tx1"/>
+                </a:solidFill>
+                <a:latin typeface="+mn-lt"/>
+                <a:ea typeface="+mn-ea"/>
+                <a:cs typeface="+mn-cs"/>
+              </a:defRPr>
+            </a:lvl1pPr>
+            <a:lvl2pPr marL="685800" indent="-228600" algn="l" defTabSz="914400" rtl="0" eaLnBrk="1" latinLnBrk="0" hangingPunct="1">
+              <a:lnSpc>
+                <a:spcPct val="90000"/>
+              </a:lnSpc>
+              <a:spcBef>
+                <a:spcPts val="500"/>
+              </a:spcBef>
+              <a:buFont typeface="Arial" panose="020B0604020202020204" pitchFamily="34" charset="0"/>
+              <a:buChar char="•"/>
+              <a:defRPr sz="2400" kern="1200">
+                <a:solidFill>
+                  <a:schemeClr val="tx1"/>
+                </a:solidFill>
+                <a:latin typeface="+mn-lt"/>
+                <a:ea typeface="+mn-ea"/>
+                <a:cs typeface="+mn-cs"/>
+              </a:defRPr>
+            </a:lvl2pPr>
+            <a:lvl3pPr marL="1143000" indent="-228600" algn="l" defTabSz="914400" rtl="0" eaLnBrk="1" latinLnBrk="0" hangingPunct="1">
+              <a:lnSpc>
+                <a:spcPct val="90000"/>
+              </a:lnSpc>
+              <a:spcBef>
+                <a:spcPts val="500"/>
+              </a:spcBef>
+              <a:buFont typeface="Arial" panose="020B0604020202020204" pitchFamily="34" charset="0"/>
+              <a:buChar char="•"/>
+              <a:defRPr sz="2000" kern="1200">
+                <a:solidFill>
+                  <a:schemeClr val="tx1"/>
+                </a:solidFill>
+                <a:latin typeface="+mn-lt"/>
+                <a:ea typeface="+mn-ea"/>
+                <a:cs typeface="+mn-cs"/>
+              </a:defRPr>
+            </a:lvl3pPr>
+            <a:lvl4pPr marL="1600200" indent="-228600" algn="l" defTabSz="914400" rtl="0" eaLnBrk="1" latinLnBrk="0" hangingPunct="1">
+              <a:lnSpc>
+                <a:spcPct val="90000"/>
+              </a:lnSpc>
+              <a:spcBef>
+                <a:spcPts val="500"/>
+              </a:spcBef>
+              <a:buFont typeface="Arial" panose="020B0604020202020204" pitchFamily="34" charset="0"/>
+              <a:buChar char="•"/>
+              <a:defRPr sz="1800" kern="1200">
+                <a:solidFill>
+                  <a:schemeClr val="tx1"/>
+                </a:solidFill>
+                <a:latin typeface="+mn-lt"/>
+                <a:ea typeface="+mn-ea"/>
+                <a:cs typeface="+mn-cs"/>
+              </a:defRPr>
+            </a:lvl4pPr>
+            <a:lvl5pPr marL="2057400" indent="-228600" algn="l" defTabSz="914400" rtl="0" eaLnBrk="1" latinLnBrk="0" hangingPunct="1">
+              <a:lnSpc>
+                <a:spcPct val="90000"/>
+              </a:lnSpc>
+              <a:spcBef>
+                <a:spcPts val="500"/>
+              </a:spcBef>
+              <a:buFont typeface="Arial" panose="020B0604020202020204" pitchFamily="34" charset="0"/>
+              <a:buChar char="•"/>
+              <a:defRPr sz="1800" kern="1200">
+                <a:solidFill>
+                  <a:schemeClr val="tx1"/>
+                </a:solidFill>
+                <a:latin typeface="+mn-lt"/>
+                <a:ea typeface="+mn-ea"/>
+                <a:cs typeface="+mn-cs"/>
+              </a:defRPr>
+            </a:lvl5pPr>
+            <a:lvl6pPr marL="2514600" indent="-228600" algn="l" defTabSz="914400" rtl="0" eaLnBrk="1" latinLnBrk="0" hangingPunct="1">
+              <a:lnSpc>
+                <a:spcPct val="90000"/>
+              </a:lnSpc>
+              <a:spcBef>
+                <a:spcPts val="500"/>
+              </a:spcBef>
+              <a:buFont typeface="Arial" panose="020B0604020202020204" pitchFamily="34" charset="0"/>
+              <a:buChar char="•"/>
+              <a:defRPr sz="1800" kern="1200">
+                <a:solidFill>
+                  <a:schemeClr val="tx1"/>
+                </a:solidFill>
+                <a:latin typeface="+mn-lt"/>
+                <a:ea typeface="+mn-ea"/>
+                <a:cs typeface="+mn-cs"/>
+              </a:defRPr>
+            </a:lvl6pPr>
+            <a:lvl7pPr marL="2971800" indent="-228600" algn="l" defTabSz="914400" rtl="0" eaLnBrk="1" latinLnBrk="0" hangingPunct="1">
+              <a:lnSpc>
+                <a:spcPct val="90000"/>
+              </a:lnSpc>
+              <a:spcBef>
+                <a:spcPts val="500"/>
+              </a:spcBef>
+              <a:buFont typeface="Arial" panose="020B0604020202020204" pitchFamily="34" charset="0"/>
+              <a:buChar char="•"/>
+              <a:defRPr sz="1800" kern="1200">
+                <a:solidFill>
+                  <a:schemeClr val="tx1"/>
+                </a:solidFill>
+                <a:latin typeface="+mn-lt"/>
+                <a:ea typeface="+mn-ea"/>
+                <a:cs typeface="+mn-cs"/>
+              </a:defRPr>
+            </a:lvl7pPr>
+            <a:lvl8pPr marL="3429000" indent="-228600" algn="l" defTabSz="914400" rtl="0" eaLnBrk="1" latinLnBrk="0" hangingPunct="1">
+              <a:lnSpc>
+                <a:spcPct val="90000"/>
+              </a:lnSpc>
+              <a:spcBef>
+                <a:spcPts val="500"/>
+              </a:spcBef>
+              <a:buFont typeface="Arial" panose="020B0604020202020204" pitchFamily="34" charset="0"/>
+              <a:buChar char="•"/>
+              <a:defRPr sz="1800" kern="1200">
+                <a:solidFill>
+                  <a:schemeClr val="tx1"/>
+                </a:solidFill>
+                <a:latin typeface="+mn-lt"/>
+                <a:ea typeface="+mn-ea"/>
+                <a:cs typeface="+mn-cs"/>
+              </a:defRPr>
+            </a:lvl8pPr>
+            <a:lvl9pPr marL="3886200" indent="-228600" algn="l" defTabSz="914400" rtl="0" eaLnBrk="1" latinLnBrk="0" hangingPunct="1">
+              <a:lnSpc>
+                <a:spcPct val="90000"/>
+              </a:lnSpc>
+              <a:spcBef>
+                <a:spcPts val="500"/>
+              </a:spcBef>
+              <a:buFont typeface="Arial" panose="020B0604020202020204" pitchFamily="34" charset="0"/>
+              <a:buChar char="•"/>
+              <a:defRPr sz="1800" kern="1200">
+                <a:solidFill>
+                  <a:schemeClr val="tx1"/>
+                </a:solidFill>
+                <a:latin typeface="+mn-lt"/>
+                <a:ea typeface="+mn-ea"/>
+                <a:cs typeface="+mn-cs"/>
+              </a:defRPr>
+            </a:lvl9pPr>
+          </a:lstStyle>
           <a:p>
             <a:pPr marL="0" indent="0">
+              <a:buFont typeface="Arial" panose="020B0604020202020204" pitchFamily="34" charset="0"/>
               <a:buNone/>
             </a:pPr>
-            <a:endParaRPr lang="en-GB" dirty="0"/>
-          </a:p>
-          <a:p>
-            <a:pPr marL="0" indent="0">
-              <a:buNone/>
-            </a:pPr>
             <a:r>
               <a:rPr lang="en-GB" dirty="0"/>
-              <a:t>To quantify the perceived annoyance of sound, a psychoacoustic model must be considered</a:t>
-            </a:r>
-          </a:p>
-          <a:p>
-            <a:pPr marL="0" indent="0">
-              <a:buNone/>
-            </a:pPr>
-            <a:endParaRPr lang="en-GB" dirty="0"/>
-          </a:p>
-          <a:p>
-            <a:pPr marL="0" indent="0">
-              <a:buNone/>
-            </a:pPr>
+              <a:t>Zwicker’s psychoacoustic model</a:t>
+            </a:r>
+          </a:p>
+          <a:p>
             <a:r>
               <a:rPr lang="en-US" dirty="0"/>
-              <a:t>Psychoacoustic annoyance can be quantified </a:t>
-            </a:r>
-            <a:r>
-              <a:rPr lang="en-GB" dirty="0"/>
-              <a:t>using Zwicker’s model which defines </a:t>
-            </a:r>
+              <a:t>Loudness</a:t>
+            </a:r>
+          </a:p>
+          <a:p>
             <a:r>
               <a:rPr lang="en-US" dirty="0"/>
-              <a:t>metrics of loudness, fluctuation strength, roughness, sharpness.</a:t>
+              <a:t>fluctuation strength</a:t>
+            </a:r>
+          </a:p>
+          <a:p>
+            <a:r>
+              <a:rPr lang="en-US" dirty="0"/>
+              <a:t>Roughness</a:t>
+            </a:r>
+          </a:p>
+          <a:p>
+            <a:r>
+              <a:rPr lang="en-US" dirty="0"/>
+              <a:t>sharpness.</a:t>
             </a:r>
           </a:p>
         </p:txBody>

</xml_diff>